<commit_message>
Add business chat mockup HTML and PNG for presentation
</commit_message>
<xml_diff>
--- a/presentation/VibeSense_AI_Presentation_v2.pptx
+++ b/presentation/VibeSense_AI_Presentation_v2.pptx
@@ -5,13 +5,13 @@
     <p:sldMasterId id="2147483648" r:id="rId1"/>
   </p:sldMasterIdLst>
   <p:sldIdLst>
-    <p:sldId id="256" r:id="rId7"/>
-    <p:sldId id="257" r:id="rId8"/>
-    <p:sldId id="258" r:id="rId9"/>
-    <p:sldId id="259" r:id="rId10"/>
-    <p:sldId id="260" r:id="rId11"/>
+    <p:sldId id="256" r:id="rId2"/>
+    <p:sldId id="257" r:id="rId3"/>
+    <p:sldId id="258" r:id="rId4"/>
+    <p:sldId id="259" r:id="rId5"/>
+    <p:sldId id="260" r:id="rId6"/>
   </p:sldIdLst>
-  <p:sldSz cx="12191695" cy="6858000" type="screen4x3"/>
+  <p:sldSz cx="12192000" cy="6858000"/>
   <p:notesSz cx="6858000" cy="9144000"/>
   <p:defaultTextStyle>
     <a:defPPr>
@@ -108,6 +108,22 @@
       </a:defRPr>
     </a:lvl9pPr>
   </p:defaultTextStyle>
+  <p:extLst>
+    <p:ext uri="{EFAFB233-063F-42B5-8137-9DF3F51BA10A}">
+      <p15:sldGuideLst xmlns:p15="http://schemas.microsoft.com/office/powerpoint/2012/main">
+        <p15:guide id="1" orient="horz" pos="2160">
+          <p15:clr>
+            <a:srgbClr val="A4A3A4"/>
+          </p15:clr>
+        </p15:guide>
+        <p15:guide id="2" pos="2880">
+          <p15:clr>
+            <a:srgbClr val="A4A3A4"/>
+          </p15:clr>
+        </p15:guide>
+      </p15:sldGuideLst>
+    </p:ext>
+  </p:extLst>
 </p:presentation>
 </file>
 
@@ -149,10 +165,9 @@
           <a:lstStyle/>
           <a:p>
             <a:r>
-              <a:rPr lang="en-US" smtClean="0"/>
+              <a:rPr lang="en-US"/>
               <a:t>Click to edit Master title style</a:t>
             </a:r>
-            <a:endParaRPr lang="en-US"/>
           </a:p>
         </p:txBody>
       </p:sp>
@@ -268,10 +283,9 @@
           </a:lstStyle>
           <a:p>
             <a:r>
-              <a:rPr lang="en-US" smtClean="0"/>
+              <a:rPr lang="en-US"/>
               <a:t>Click to edit Master subtitle style</a:t>
             </a:r>
-            <a:endParaRPr lang="en-US"/>
           </a:p>
         </p:txBody>
       </p:sp>
@@ -292,7 +306,7 @@
           <a:p>
             <a:fld id="{5BCAD085-E8A6-8845-BD4E-CB4CCA059FC4}" type="datetimeFigureOut">
               <a:rPr lang="en-US" smtClean="0"/>
-              <a:t>1/27/13</a:t>
+              <a:t>10/31/2026</a:t>
             </a:fld>
             <a:endParaRPr lang="en-US"/>
           </a:p>
@@ -386,10 +400,9 @@
           <a:lstStyle/>
           <a:p>
             <a:r>
-              <a:rPr lang="en-US" smtClean="0"/>
+              <a:rPr lang="en-US"/>
               <a:t>Click to edit Master title style</a:t>
             </a:r>
-            <a:endParaRPr lang="en-US"/>
           </a:p>
         </p:txBody>
       </p:sp>
@@ -410,38 +423,37 @@
           <a:p>
             <a:pPr lvl="0"/>
             <a:r>
-              <a:rPr lang="en-US" smtClean="0"/>
+              <a:rPr lang="en-US"/>
               <a:t>Click to edit Master text styles</a:t>
             </a:r>
           </a:p>
           <a:p>
             <a:pPr lvl="1"/>
             <a:r>
-              <a:rPr lang="en-US" smtClean="0"/>
+              <a:rPr lang="en-US"/>
               <a:t>Second level</a:t>
             </a:r>
           </a:p>
           <a:p>
             <a:pPr lvl="2"/>
             <a:r>
-              <a:rPr lang="en-US" smtClean="0"/>
+              <a:rPr lang="en-US"/>
               <a:t>Third level</a:t>
             </a:r>
           </a:p>
           <a:p>
             <a:pPr lvl="3"/>
             <a:r>
-              <a:rPr lang="en-US" smtClean="0"/>
+              <a:rPr lang="en-US"/>
               <a:t>Fourth level</a:t>
             </a:r>
           </a:p>
           <a:p>
             <a:pPr lvl="4"/>
             <a:r>
-              <a:rPr lang="en-US" smtClean="0"/>
+              <a:rPr lang="en-US"/>
               <a:t>Fifth level</a:t>
             </a:r>
-            <a:endParaRPr lang="en-US"/>
           </a:p>
         </p:txBody>
       </p:sp>
@@ -462,7 +474,7 @@
           <a:p>
             <a:fld id="{5BCAD085-E8A6-8845-BD4E-CB4CCA059FC4}" type="datetimeFigureOut">
               <a:rPr lang="en-US" smtClean="0"/>
-              <a:t>1/27/13</a:t>
+              <a:t>10/31/2026</a:t>
             </a:fld>
             <a:endParaRPr lang="en-US"/>
           </a:p>
@@ -561,10 +573,9 @@
           <a:lstStyle/>
           <a:p>
             <a:r>
-              <a:rPr lang="en-US" smtClean="0"/>
+              <a:rPr lang="en-US"/>
               <a:t>Click to edit Master title style</a:t>
             </a:r>
-            <a:endParaRPr lang="en-US"/>
           </a:p>
         </p:txBody>
       </p:sp>
@@ -590,38 +601,37 @@
           <a:p>
             <a:pPr lvl="0"/>
             <a:r>
-              <a:rPr lang="en-US" smtClean="0"/>
+              <a:rPr lang="en-US"/>
               <a:t>Click to edit Master text styles</a:t>
             </a:r>
           </a:p>
           <a:p>
             <a:pPr lvl="1"/>
             <a:r>
-              <a:rPr lang="en-US" smtClean="0"/>
+              <a:rPr lang="en-US"/>
               <a:t>Second level</a:t>
             </a:r>
           </a:p>
           <a:p>
             <a:pPr lvl="2"/>
             <a:r>
-              <a:rPr lang="en-US" smtClean="0"/>
+              <a:rPr lang="en-US"/>
               <a:t>Third level</a:t>
             </a:r>
           </a:p>
           <a:p>
             <a:pPr lvl="3"/>
             <a:r>
-              <a:rPr lang="en-US" smtClean="0"/>
+              <a:rPr lang="en-US"/>
               <a:t>Fourth level</a:t>
             </a:r>
           </a:p>
           <a:p>
             <a:pPr lvl="4"/>
             <a:r>
-              <a:rPr lang="en-US" smtClean="0"/>
+              <a:rPr lang="en-US"/>
               <a:t>Fifth level</a:t>
             </a:r>
-            <a:endParaRPr lang="en-US"/>
           </a:p>
         </p:txBody>
       </p:sp>
@@ -642,7 +652,7 @@
           <a:p>
             <a:fld id="{5BCAD085-E8A6-8845-BD4E-CB4CCA059FC4}" type="datetimeFigureOut">
               <a:rPr lang="en-US" smtClean="0"/>
-              <a:t>1/27/13</a:t>
+              <a:t>10/31/2026</a:t>
             </a:fld>
             <a:endParaRPr lang="en-US"/>
           </a:p>
@@ -736,10 +746,9 @@
           <a:lstStyle/>
           <a:p>
             <a:r>
-              <a:rPr lang="en-US" smtClean="0"/>
+              <a:rPr lang="en-US"/>
               <a:t>Click to edit Master title style</a:t>
             </a:r>
-            <a:endParaRPr lang="en-US"/>
           </a:p>
         </p:txBody>
       </p:sp>
@@ -760,38 +769,37 @@
           <a:p>
             <a:pPr lvl="0"/>
             <a:r>
-              <a:rPr lang="en-US" smtClean="0"/>
+              <a:rPr lang="en-US"/>
               <a:t>Click to edit Master text styles</a:t>
             </a:r>
           </a:p>
           <a:p>
             <a:pPr lvl="1"/>
             <a:r>
-              <a:rPr lang="en-US" smtClean="0"/>
+              <a:rPr lang="en-US"/>
               <a:t>Second level</a:t>
             </a:r>
           </a:p>
           <a:p>
             <a:pPr lvl="2"/>
             <a:r>
-              <a:rPr lang="en-US" smtClean="0"/>
+              <a:rPr lang="en-US"/>
               <a:t>Third level</a:t>
             </a:r>
           </a:p>
           <a:p>
             <a:pPr lvl="3"/>
             <a:r>
-              <a:rPr lang="en-US" smtClean="0"/>
+              <a:rPr lang="en-US"/>
               <a:t>Fourth level</a:t>
             </a:r>
           </a:p>
           <a:p>
             <a:pPr lvl="4"/>
             <a:r>
-              <a:rPr lang="en-US" smtClean="0"/>
+              <a:rPr lang="en-US"/>
               <a:t>Fifth level</a:t>
             </a:r>
-            <a:endParaRPr lang="en-US"/>
           </a:p>
         </p:txBody>
       </p:sp>
@@ -812,7 +820,7 @@
           <a:p>
             <a:fld id="{5BCAD085-E8A6-8845-BD4E-CB4CCA059FC4}" type="datetimeFigureOut">
               <a:rPr lang="en-US" smtClean="0"/>
-              <a:t>1/27/13</a:t>
+              <a:t>10/31/2026</a:t>
             </a:fld>
             <a:endParaRPr lang="en-US"/>
           </a:p>
@@ -915,10 +923,9 @@
           </a:lstStyle>
           <a:p>
             <a:r>
-              <a:rPr lang="en-US" smtClean="0"/>
+              <a:rPr lang="en-US"/>
               <a:t>Click to edit Master title style</a:t>
             </a:r>
-            <a:endParaRPr lang="en-US"/>
           </a:p>
         </p:txBody>
       </p:sp>
@@ -1035,7 +1042,7 @@
           <a:p>
             <a:pPr lvl="0"/>
             <a:r>
-              <a:rPr lang="en-US" smtClean="0"/>
+              <a:rPr lang="en-US"/>
               <a:t>Click to edit Master text styles</a:t>
             </a:r>
           </a:p>
@@ -1058,7 +1065,7 @@
           <a:p>
             <a:fld id="{5BCAD085-E8A6-8845-BD4E-CB4CCA059FC4}" type="datetimeFigureOut">
               <a:rPr lang="en-US" smtClean="0"/>
-              <a:t>1/27/13</a:t>
+              <a:t>10/31/2026</a:t>
             </a:fld>
             <a:endParaRPr lang="en-US"/>
           </a:p>
@@ -1152,10 +1159,9 @@
           <a:lstStyle/>
           <a:p>
             <a:r>
-              <a:rPr lang="en-US" smtClean="0"/>
+              <a:rPr lang="en-US"/>
               <a:t>Click to edit Master title style</a:t>
             </a:r>
-            <a:endParaRPr lang="en-US"/>
           </a:p>
         </p:txBody>
       </p:sp>
@@ -1209,38 +1215,37 @@
           <a:p>
             <a:pPr lvl="0"/>
             <a:r>
-              <a:rPr lang="en-US" smtClean="0"/>
+              <a:rPr lang="en-US"/>
               <a:t>Click to edit Master text styles</a:t>
             </a:r>
           </a:p>
           <a:p>
             <a:pPr lvl="1"/>
             <a:r>
-              <a:rPr lang="en-US" smtClean="0"/>
+              <a:rPr lang="en-US"/>
               <a:t>Second level</a:t>
             </a:r>
           </a:p>
           <a:p>
             <a:pPr lvl="2"/>
             <a:r>
-              <a:rPr lang="en-US" smtClean="0"/>
+              <a:rPr lang="en-US"/>
               <a:t>Third level</a:t>
             </a:r>
           </a:p>
           <a:p>
             <a:pPr lvl="3"/>
             <a:r>
-              <a:rPr lang="en-US" smtClean="0"/>
+              <a:rPr lang="en-US"/>
               <a:t>Fourth level</a:t>
             </a:r>
           </a:p>
           <a:p>
             <a:pPr lvl="4"/>
             <a:r>
-              <a:rPr lang="en-US" smtClean="0"/>
+              <a:rPr lang="en-US"/>
               <a:t>Fifth level</a:t>
             </a:r>
-            <a:endParaRPr lang="en-US"/>
           </a:p>
         </p:txBody>
       </p:sp>
@@ -1294,38 +1299,37 @@
           <a:p>
             <a:pPr lvl="0"/>
             <a:r>
-              <a:rPr lang="en-US" smtClean="0"/>
+              <a:rPr lang="en-US"/>
               <a:t>Click to edit Master text styles</a:t>
             </a:r>
           </a:p>
           <a:p>
             <a:pPr lvl="1"/>
             <a:r>
-              <a:rPr lang="en-US" smtClean="0"/>
+              <a:rPr lang="en-US"/>
               <a:t>Second level</a:t>
             </a:r>
           </a:p>
           <a:p>
             <a:pPr lvl="2"/>
             <a:r>
-              <a:rPr lang="en-US" smtClean="0"/>
+              <a:rPr lang="en-US"/>
               <a:t>Third level</a:t>
             </a:r>
           </a:p>
           <a:p>
             <a:pPr lvl="3"/>
             <a:r>
-              <a:rPr lang="en-US" smtClean="0"/>
+              <a:rPr lang="en-US"/>
               <a:t>Fourth level</a:t>
             </a:r>
           </a:p>
           <a:p>
             <a:pPr lvl="4"/>
             <a:r>
-              <a:rPr lang="en-US" smtClean="0"/>
+              <a:rPr lang="en-US"/>
               <a:t>Fifth level</a:t>
             </a:r>
-            <a:endParaRPr lang="en-US"/>
           </a:p>
         </p:txBody>
       </p:sp>
@@ -1346,7 +1350,7 @@
           <a:p>
             <a:fld id="{5BCAD085-E8A6-8845-BD4E-CB4CCA059FC4}" type="datetimeFigureOut">
               <a:rPr lang="en-US" smtClean="0"/>
-              <a:t>1/27/13</a:t>
+              <a:t>10/31/2026</a:t>
             </a:fld>
             <a:endParaRPr lang="en-US"/>
           </a:p>
@@ -1444,10 +1448,9 @@
           </a:lstStyle>
           <a:p>
             <a:r>
-              <a:rPr lang="en-US" smtClean="0"/>
+              <a:rPr lang="en-US"/>
               <a:t>Click to edit Master title style</a:t>
             </a:r>
-            <a:endParaRPr lang="en-US"/>
           </a:p>
         </p:txBody>
       </p:sp>
@@ -1510,7 +1513,7 @@
           <a:p>
             <a:pPr lvl="0"/>
             <a:r>
-              <a:rPr lang="en-US" smtClean="0"/>
+              <a:rPr lang="en-US"/>
               <a:t>Click to edit Master text styles</a:t>
             </a:r>
           </a:p>
@@ -1566,38 +1569,37 @@
           <a:p>
             <a:pPr lvl="0"/>
             <a:r>
-              <a:rPr lang="en-US" smtClean="0"/>
+              <a:rPr lang="en-US"/>
               <a:t>Click to edit Master text styles</a:t>
             </a:r>
           </a:p>
           <a:p>
             <a:pPr lvl="1"/>
             <a:r>
-              <a:rPr lang="en-US" smtClean="0"/>
+              <a:rPr lang="en-US"/>
               <a:t>Second level</a:t>
             </a:r>
           </a:p>
           <a:p>
             <a:pPr lvl="2"/>
             <a:r>
-              <a:rPr lang="en-US" smtClean="0"/>
+              <a:rPr lang="en-US"/>
               <a:t>Third level</a:t>
             </a:r>
           </a:p>
           <a:p>
             <a:pPr lvl="3"/>
             <a:r>
-              <a:rPr lang="en-US" smtClean="0"/>
+              <a:rPr lang="en-US"/>
               <a:t>Fourth level</a:t>
             </a:r>
           </a:p>
           <a:p>
             <a:pPr lvl="4"/>
             <a:r>
-              <a:rPr lang="en-US" smtClean="0"/>
+              <a:rPr lang="en-US"/>
               <a:t>Fifth level</a:t>
             </a:r>
-            <a:endParaRPr lang="en-US"/>
           </a:p>
         </p:txBody>
       </p:sp>
@@ -1660,7 +1662,7 @@
           <a:p>
             <a:pPr lvl="0"/>
             <a:r>
-              <a:rPr lang="en-US" smtClean="0"/>
+              <a:rPr lang="en-US"/>
               <a:t>Click to edit Master text styles</a:t>
             </a:r>
           </a:p>
@@ -1716,38 +1718,37 @@
           <a:p>
             <a:pPr lvl="0"/>
             <a:r>
-              <a:rPr lang="en-US" smtClean="0"/>
+              <a:rPr lang="en-US"/>
               <a:t>Click to edit Master text styles</a:t>
             </a:r>
           </a:p>
           <a:p>
             <a:pPr lvl="1"/>
             <a:r>
-              <a:rPr lang="en-US" smtClean="0"/>
+              <a:rPr lang="en-US"/>
               <a:t>Second level</a:t>
             </a:r>
           </a:p>
           <a:p>
             <a:pPr lvl="2"/>
             <a:r>
-              <a:rPr lang="en-US" smtClean="0"/>
+              <a:rPr lang="en-US"/>
               <a:t>Third level</a:t>
             </a:r>
           </a:p>
           <a:p>
             <a:pPr lvl="3"/>
             <a:r>
-              <a:rPr lang="en-US" smtClean="0"/>
+              <a:rPr lang="en-US"/>
               <a:t>Fourth level</a:t>
             </a:r>
           </a:p>
           <a:p>
             <a:pPr lvl="4"/>
             <a:r>
-              <a:rPr lang="en-US" smtClean="0"/>
+              <a:rPr lang="en-US"/>
               <a:t>Fifth level</a:t>
             </a:r>
-            <a:endParaRPr lang="en-US"/>
           </a:p>
         </p:txBody>
       </p:sp>
@@ -1768,7 +1769,7 @@
           <a:p>
             <a:fld id="{5BCAD085-E8A6-8845-BD4E-CB4CCA059FC4}" type="datetimeFigureOut">
               <a:rPr lang="en-US" smtClean="0"/>
-              <a:t>1/27/13</a:t>
+              <a:t>10/31/2026</a:t>
             </a:fld>
             <a:endParaRPr lang="en-US"/>
           </a:p>
@@ -1862,10 +1863,9 @@
           <a:lstStyle/>
           <a:p>
             <a:r>
-              <a:rPr lang="en-US" smtClean="0"/>
+              <a:rPr lang="en-US"/>
               <a:t>Click to edit Master title style</a:t>
             </a:r>
-            <a:endParaRPr lang="en-US"/>
           </a:p>
         </p:txBody>
       </p:sp>
@@ -1886,7 +1886,7 @@
           <a:p>
             <a:fld id="{5BCAD085-E8A6-8845-BD4E-CB4CCA059FC4}" type="datetimeFigureOut">
               <a:rPr lang="en-US" smtClean="0"/>
-              <a:t>1/27/13</a:t>
+              <a:t>10/31/2026</a:t>
             </a:fld>
             <a:endParaRPr lang="en-US"/>
           </a:p>
@@ -1981,7 +1981,7 @@
           <a:p>
             <a:fld id="{5BCAD085-E8A6-8845-BD4E-CB4CCA059FC4}" type="datetimeFigureOut">
               <a:rPr lang="en-US" smtClean="0"/>
-              <a:t>1/27/13</a:t>
+              <a:t>10/31/2026</a:t>
             </a:fld>
             <a:endParaRPr lang="en-US"/>
           </a:p>
@@ -2084,10 +2084,9 @@
           </a:lstStyle>
           <a:p>
             <a:r>
-              <a:rPr lang="en-US" smtClean="0"/>
+              <a:rPr lang="en-US"/>
               <a:t>Click to edit Master title style</a:t>
             </a:r>
-            <a:endParaRPr lang="en-US"/>
           </a:p>
         </p:txBody>
       </p:sp>
@@ -2141,38 +2140,37 @@
           <a:p>
             <a:pPr lvl="0"/>
             <a:r>
-              <a:rPr lang="en-US" smtClean="0"/>
+              <a:rPr lang="en-US"/>
               <a:t>Click to edit Master text styles</a:t>
             </a:r>
           </a:p>
           <a:p>
             <a:pPr lvl="1"/>
             <a:r>
-              <a:rPr lang="en-US" smtClean="0"/>
+              <a:rPr lang="en-US"/>
               <a:t>Second level</a:t>
             </a:r>
           </a:p>
           <a:p>
             <a:pPr lvl="2"/>
             <a:r>
-              <a:rPr lang="en-US" smtClean="0"/>
+              <a:rPr lang="en-US"/>
               <a:t>Third level</a:t>
             </a:r>
           </a:p>
           <a:p>
             <a:pPr lvl="3"/>
             <a:r>
-              <a:rPr lang="en-US" smtClean="0"/>
+              <a:rPr lang="en-US"/>
               <a:t>Fourth level</a:t>
             </a:r>
           </a:p>
           <a:p>
             <a:pPr lvl="4"/>
             <a:r>
-              <a:rPr lang="en-US" smtClean="0"/>
+              <a:rPr lang="en-US"/>
               <a:t>Fifth level</a:t>
             </a:r>
-            <a:endParaRPr lang="en-US"/>
           </a:p>
         </p:txBody>
       </p:sp>
@@ -2235,7 +2233,7 @@
           <a:p>
             <a:pPr lvl="0"/>
             <a:r>
-              <a:rPr lang="en-US" smtClean="0"/>
+              <a:rPr lang="en-US"/>
               <a:t>Click to edit Master text styles</a:t>
             </a:r>
           </a:p>
@@ -2258,7 +2256,7 @@
           <a:p>
             <a:fld id="{5BCAD085-E8A6-8845-BD4E-CB4CCA059FC4}" type="datetimeFigureOut">
               <a:rPr lang="en-US" smtClean="0"/>
-              <a:t>1/27/13</a:t>
+              <a:t>10/31/2026</a:t>
             </a:fld>
             <a:endParaRPr lang="en-US"/>
           </a:p>
@@ -2361,10 +2359,9 @@
           </a:lstStyle>
           <a:p>
             <a:r>
-              <a:rPr lang="en-US" smtClean="0"/>
+              <a:rPr lang="en-US"/>
               <a:t>Click to edit Master title style</a:t>
             </a:r>
-            <a:endParaRPr lang="en-US"/>
           </a:p>
         </p:txBody>
       </p:sp>
@@ -2488,7 +2485,7 @@
           <a:p>
             <a:pPr lvl="0"/>
             <a:r>
-              <a:rPr lang="en-US" smtClean="0"/>
+              <a:rPr lang="en-US"/>
               <a:t>Click to edit Master text styles</a:t>
             </a:r>
           </a:p>
@@ -2511,7 +2508,7 @@
           <a:p>
             <a:fld id="{5BCAD085-E8A6-8845-BD4E-CB4CCA059FC4}" type="datetimeFigureOut">
               <a:rPr lang="en-US" smtClean="0"/>
-              <a:t>1/27/13</a:t>
+              <a:t>10/31/2026</a:t>
             </a:fld>
             <a:endParaRPr lang="en-US"/>
           </a:p>
@@ -2620,10 +2617,9 @@
           <a:lstStyle/>
           <a:p>
             <a:r>
-              <a:rPr lang="en-US" smtClean="0"/>
+              <a:rPr lang="en-US"/>
               <a:t>Click to edit Master title style</a:t>
             </a:r>
-            <a:endParaRPr lang="en-US"/>
           </a:p>
         </p:txBody>
       </p:sp>
@@ -2654,38 +2650,37 @@
           <a:p>
             <a:pPr lvl="0"/>
             <a:r>
-              <a:rPr lang="en-US" smtClean="0"/>
+              <a:rPr lang="en-US"/>
               <a:t>Click to edit Master text styles</a:t>
             </a:r>
           </a:p>
           <a:p>
             <a:pPr lvl="1"/>
             <a:r>
-              <a:rPr lang="en-US" smtClean="0"/>
+              <a:rPr lang="en-US"/>
               <a:t>Second level</a:t>
             </a:r>
           </a:p>
           <a:p>
             <a:pPr lvl="2"/>
             <a:r>
-              <a:rPr lang="en-US" smtClean="0"/>
+              <a:rPr lang="en-US"/>
               <a:t>Third level</a:t>
             </a:r>
           </a:p>
           <a:p>
             <a:pPr lvl="3"/>
             <a:r>
-              <a:rPr lang="en-US" smtClean="0"/>
+              <a:rPr lang="en-US"/>
               <a:t>Fourth level</a:t>
             </a:r>
           </a:p>
           <a:p>
             <a:pPr lvl="4"/>
             <a:r>
-              <a:rPr lang="en-US" smtClean="0"/>
+              <a:rPr lang="en-US"/>
               <a:t>Fifth level</a:t>
             </a:r>
-            <a:endParaRPr lang="en-US"/>
           </a:p>
         </p:txBody>
       </p:sp>
@@ -2724,7 +2719,7 @@
           <a:p>
             <a:fld id="{5BCAD085-E8A6-8845-BD4E-CB4CCA059FC4}" type="datetimeFigureOut">
               <a:rPr lang="en-US" smtClean="0"/>
-              <a:t>1/27/13</a:t>
+              <a:t>10/31/2026</a:t>
             </a:fld>
             <a:endParaRPr lang="en-US"/>
           </a:p>
@@ -3083,7 +3078,7 @@
 </file>
 
 <file path=ppt/slides/slide1.xml><?xml version="1.0" encoding="utf-8"?>
-<p:sld xmlns:a="http://schemas.openxmlformats.org/drawingml/2006/main" xmlns:p="http://schemas.openxmlformats.org/presentationml/2006/main" xmlns:r="http://schemas.openxmlformats.org/officeDocument/2006/relationships">
+<p:sld xmlns:a="http://schemas.openxmlformats.org/drawingml/2006/main" xmlns:r="http://schemas.openxmlformats.org/officeDocument/2006/relationships" xmlns:p="http://schemas.openxmlformats.org/presentationml/2006/main">
   <p:cSld>
     <p:spTree>
       <p:nvGrpSpPr>
@@ -3091,7 +3086,14 @@
         <p:cNvGrpSpPr/>
         <p:nvPr/>
       </p:nvGrpSpPr>
-      <p:grpSpPr/>
+      <p:grpSpPr>
+        <a:xfrm>
+          <a:off x="0" y="0"/>
+          <a:ext cx="0" cy="0"/>
+          <a:chOff x="0" y="0"/>
+          <a:chExt cx="0" cy="0"/>
+        </a:xfrm>
+      </p:grpSpPr>
       <p:sp>
         <p:nvSpPr>
           <p:cNvPr id="2" name="Rectangle 1"/>
@@ -3132,6 +3134,7 @@
           <a:lstStyle/>
           <a:p>
             <a:pPr algn="ctr"/>
+            <a:endParaRPr/>
           </a:p>
         </p:txBody>
       </p:sp>
@@ -3175,61 +3178,7 @@
           <a:lstStyle/>
           <a:p>
             <a:pPr algn="ctr"/>
-          </a:p>
-        </p:txBody>
-      </p:sp>
-      <p:sp>
-        <p:nvSpPr>
-          <p:cNvPr id="4" name="Rounded Rectangle 3"/>
-          <p:cNvSpPr/>
-          <p:nvPr/>
-        </p:nvSpPr>
-        <p:spPr>
-          <a:xfrm>
-            <a:off x="1097280" y="1097280"/>
-            <a:ext cx="3108960" cy="347472"/>
-          </a:xfrm>
-          <a:prstGeom prst="roundRect">
-            <a:avLst/>
-          </a:prstGeom>
-          <a:solidFill>
-            <a:srgbClr val="102422"/>
-          </a:solidFill>
-          <a:ln w="12700">
-            <a:solidFill>
-              <a:srgbClr val="06B6D4"/>
-            </a:solidFill>
-          </a:ln>
-        </p:spPr>
-        <p:style>
-          <a:lnRef idx="1">
-            <a:schemeClr val="accent1"/>
-          </a:lnRef>
-          <a:fillRef idx="3">
-            <a:schemeClr val="accent1"/>
-          </a:fillRef>
-          <a:effectRef idx="2">
-            <a:schemeClr val="accent1"/>
-          </a:effectRef>
-          <a:fontRef idx="minor">
-            <a:schemeClr val="lt1"/>
-          </a:fontRef>
-        </p:style>
-        <p:txBody>
-          <a:bodyPr rtlCol="0" anchor="ctr" wrap="square" lIns="0" rIns="0" tIns="0" bIns="0"/>
-          <a:lstStyle/>
-          <a:p>
-            <a:pPr algn="ctr">
-              <a:defRPr sz="1100" b="1">
-                <a:solidFill>
-                  <a:srgbClr val="06B6D4"/>
-                </a:solidFill>
-                <a:latin typeface="Segoe UI"/>
-              </a:defRPr>
-            </a:pPr>
-            <a:r>
-              <a:t>ПРОЕКТ НА КОНКУРС • AI ASSISTANT</a:t>
-            </a:r>
+            <a:endParaRPr/>
           </a:p>
         </p:txBody>
       </p:sp>
@@ -3315,7 +3264,7 @@
         <p:spPr>
           <a:xfrm>
             <a:off x="1097280" y="3108960"/>
-            <a:ext cx="9966960" cy="1005840"/>
+            <a:ext cx="9966960" cy="584775"/>
           </a:xfrm>
           <a:prstGeom prst="rect">
             <a:avLst/>
@@ -3337,32 +3286,314 @@
               </a:defRPr>
             </a:pPr>
             <a:r>
-              <a:t>Умный десктопный ассистент для Windows: анализирует скрытый подтекст диалогов в любых мессенджерах и помогает сформулировать идеальный ответ под конкретную цель.</a:t>
-            </a:r>
-          </a:p>
-        </p:txBody>
-      </p:sp>
-      <p:sp>
-        <p:nvSpPr>
-          <p:cNvPr id="8" name="Rounded Rectangle 7"/>
+              <a:rPr sz="1600" dirty="0" err="1"/>
+              <a:t>Умный</a:t>
+            </a:r>
+            <a:r>
+              <a:rPr sz="1600" dirty="0"/>
+              <a:t> </a:t>
+            </a:r>
+            <a:r>
+              <a:rPr sz="1600" dirty="0" err="1"/>
+              <a:t>десктопный</a:t>
+            </a:r>
+            <a:r>
+              <a:rPr sz="1600" dirty="0"/>
+              <a:t> </a:t>
+            </a:r>
+            <a:r>
+              <a:rPr sz="1600" dirty="0" err="1"/>
+              <a:t>ассистент</a:t>
+            </a:r>
+            <a:r>
+              <a:rPr sz="1600" dirty="0"/>
+              <a:t> </a:t>
+            </a:r>
+            <a:r>
+              <a:rPr sz="1600" dirty="0" err="1"/>
+              <a:t>для</a:t>
+            </a:r>
+            <a:r>
+              <a:rPr sz="1600" dirty="0"/>
+              <a:t> Windows: </a:t>
+            </a:r>
+            <a:r>
+              <a:rPr sz="1600" dirty="0" err="1"/>
+              <a:t>анализирует</a:t>
+            </a:r>
+            <a:r>
+              <a:rPr sz="1600" dirty="0"/>
+              <a:t> </a:t>
+            </a:r>
+            <a:r>
+              <a:rPr sz="1600" dirty="0" err="1"/>
+              <a:t>скрытый</a:t>
+            </a:r>
+            <a:r>
+              <a:rPr sz="1600" dirty="0"/>
+              <a:t> </a:t>
+            </a:r>
+            <a:r>
+              <a:rPr sz="1600" dirty="0" err="1"/>
+              <a:t>подтекст</a:t>
+            </a:r>
+            <a:r>
+              <a:rPr sz="1600" dirty="0"/>
+              <a:t> </a:t>
+            </a:r>
+            <a:r>
+              <a:rPr sz="1600" dirty="0" err="1"/>
+              <a:t>диалогов</a:t>
+            </a:r>
+            <a:r>
+              <a:rPr sz="1600" dirty="0"/>
+              <a:t> в </a:t>
+            </a:r>
+            <a:r>
+              <a:rPr sz="1600" dirty="0" err="1"/>
+              <a:t>любых</a:t>
+            </a:r>
+            <a:r>
+              <a:rPr sz="1600" dirty="0"/>
+              <a:t> </a:t>
+            </a:r>
+            <a:r>
+              <a:rPr sz="1600" dirty="0" err="1"/>
+              <a:t>мессенджерах</a:t>
+            </a:r>
+            <a:r>
+              <a:rPr sz="1600" dirty="0"/>
+              <a:t> и </a:t>
+            </a:r>
+            <a:r>
+              <a:rPr sz="1600" dirty="0" err="1"/>
+              <a:t>помогает</a:t>
+            </a:r>
+            <a:r>
+              <a:rPr sz="1600" dirty="0"/>
+              <a:t> </a:t>
+            </a:r>
+            <a:r>
+              <a:rPr sz="1600" dirty="0" err="1"/>
+              <a:t>сформулировать</a:t>
+            </a:r>
+            <a:r>
+              <a:rPr sz="1600" dirty="0"/>
+              <a:t> </a:t>
+            </a:r>
+            <a:r>
+              <a:rPr sz="1600" dirty="0" err="1"/>
+              <a:t>идеальный</a:t>
+            </a:r>
+            <a:r>
+              <a:rPr sz="1600" dirty="0"/>
+              <a:t> </a:t>
+            </a:r>
+            <a:r>
+              <a:rPr sz="1600" dirty="0" err="1"/>
+              <a:t>ответ</a:t>
+            </a:r>
+            <a:r>
+              <a:rPr sz="1600" dirty="0"/>
+              <a:t> </a:t>
+            </a:r>
+            <a:r>
+              <a:rPr sz="1600" dirty="0" err="1"/>
+              <a:t>под</a:t>
+            </a:r>
+            <a:r>
+              <a:rPr sz="1600" dirty="0"/>
+              <a:t> </a:t>
+            </a:r>
+            <a:r>
+              <a:rPr sz="1600" dirty="0" err="1"/>
+              <a:t>конкретную</a:t>
+            </a:r>
+            <a:r>
+              <a:rPr sz="1600" dirty="0"/>
+              <a:t> </a:t>
+            </a:r>
+            <a:r>
+              <a:rPr sz="1600" dirty="0" err="1"/>
+              <a:t>цель</a:t>
+            </a:r>
+            <a:r>
+              <a:rPr sz="1600" dirty="0"/>
+              <a:t>.</a:t>
+            </a:r>
+          </a:p>
+        </p:txBody>
+      </p:sp>
+      <p:grpSp>
+        <p:nvGrpSpPr>
+          <p:cNvPr id="14" name="Группа 13">
+            <a:extLst>
+              <a:ext uri="{FF2B5EF4-FFF2-40B4-BE49-F238E27FC236}">
+                <a16:creationId xmlns:a16="http://schemas.microsoft.com/office/drawing/2014/main" id="{D6FD2201-F1E4-9162-E8F2-7FFBA0274941}"/>
+              </a:ext>
+            </a:extLst>
+          </p:cNvPr>
+          <p:cNvGrpSpPr/>
+          <p:nvPr/>
+        </p:nvGrpSpPr>
+        <p:grpSpPr>
+          <a:xfrm>
+            <a:off x="7516269" y="4227604"/>
+            <a:ext cx="3747934" cy="1141995"/>
+            <a:chOff x="7124282" y="4434840"/>
+            <a:chExt cx="3747934" cy="1141995"/>
+          </a:xfrm>
+        </p:grpSpPr>
+        <p:sp>
+          <p:nvSpPr>
+            <p:cNvPr id="12" name="Rounded Rectangle 11"/>
+            <p:cNvSpPr/>
+            <p:nvPr/>
+          </p:nvSpPr>
+          <p:spPr>
+            <a:xfrm>
+              <a:off x="7124282" y="4434840"/>
+              <a:ext cx="3421464" cy="1141995"/>
+            </a:xfrm>
+            <a:prstGeom prst="roundRect">
+              <a:avLst/>
+            </a:prstGeom>
+            <a:solidFill>
+              <a:srgbClr val="161E2C"/>
+            </a:solidFill>
+            <a:ln w="12700">
+              <a:solidFill>
+                <a:srgbClr val="2E3B52"/>
+              </a:solidFill>
+            </a:ln>
+          </p:spPr>
+          <p:style>
+            <a:lnRef idx="1">
+              <a:schemeClr val="accent1"/>
+            </a:lnRef>
+            <a:fillRef idx="3">
+              <a:schemeClr val="accent1"/>
+            </a:fillRef>
+            <a:effectRef idx="2">
+              <a:schemeClr val="accent1"/>
+            </a:effectRef>
+            <a:fontRef idx="minor">
+              <a:schemeClr val="lt1"/>
+            </a:fontRef>
+          </p:style>
+          <p:txBody>
+            <a:bodyPr rtlCol="0" anchor="ctr"/>
+            <a:lstStyle/>
+            <a:p>
+              <a:pPr algn="ctr"/>
+              <a:endParaRPr/>
+            </a:p>
+          </p:txBody>
+        </p:sp>
+        <p:sp>
+          <p:nvSpPr>
+            <p:cNvPr id="13" name="TextBox 12"/>
+            <p:cNvSpPr txBox="1"/>
+            <p:nvPr/>
+          </p:nvSpPr>
+          <p:spPr>
+            <a:xfrm>
+              <a:off x="7229789" y="4514850"/>
+              <a:ext cx="3642427" cy="907941"/>
+            </a:xfrm>
+            <a:prstGeom prst="rect">
+              <a:avLst/>
+            </a:prstGeom>
+            <a:noFill/>
+          </p:spPr>
+          <p:txBody>
+            <a:bodyPr wrap="square">
+              <a:spAutoFit/>
+            </a:bodyPr>
+            <a:lstStyle/>
+            <a:p>
+              <a:pPr>
+                <a:lnSpc>
+                  <a:spcPct val="150000"/>
+                </a:lnSpc>
+                <a:defRPr sz="1400" b="1">
+                  <a:solidFill>
+                    <a:srgbClr val="FFFFFF"/>
+                  </a:solidFill>
+                  <a:latin typeface="Segoe UI"/>
+                </a:defRPr>
+              </a:pPr>
+              <a:r>
+                <a:rPr lang="ru-RU" dirty="0"/>
+                <a:t>Выполнили:</a:t>
+              </a:r>
+              <a:endParaRPr dirty="0"/>
+            </a:p>
+            <a:p>
+              <a:pPr>
+                <a:defRPr sz="1100">
+                  <a:solidFill>
+                    <a:srgbClr val="94A3B8"/>
+                  </a:solidFill>
+                  <a:latin typeface="Segoe UI"/>
+                </a:defRPr>
+              </a:pPr>
+              <a:r>
+                <a:rPr lang="ru-RU" sz="1600" dirty="0"/>
+                <a:t>▪️ Душенков Егор Владимирович</a:t>
+              </a:r>
+            </a:p>
+            <a:p>
+              <a:pPr>
+                <a:defRPr sz="1100">
+                  <a:solidFill>
+                    <a:srgbClr val="94A3B8"/>
+                  </a:solidFill>
+                  <a:latin typeface="Segoe UI"/>
+                </a:defRPr>
+              </a:pPr>
+              <a:r>
+                <a:rPr lang="ru-RU" sz="1600" dirty="0"/>
+                <a:t>▪️ </a:t>
+              </a:r>
+              <a:r>
+                <a:rPr lang="ru-RU" sz="1600" dirty="0" err="1"/>
+                <a:t>Дейкин</a:t>
+              </a:r>
+              <a:r>
+                <a:rPr lang="ru-RU" sz="1600" dirty="0"/>
+                <a:t> Артем Михайлович</a:t>
+              </a:r>
+              <a:endParaRPr sz="1600" dirty="0"/>
+            </a:p>
+          </p:txBody>
+        </p:sp>
+      </p:grpSp>
+      <p:sp>
+        <p:nvSpPr>
+          <p:cNvPr id="15" name="Rectangle 2">
+            <a:extLst>
+              <a:ext uri="{FF2B5EF4-FFF2-40B4-BE49-F238E27FC236}">
+                <a16:creationId xmlns:a16="http://schemas.microsoft.com/office/drawing/2014/main" id="{62615EEC-5ED1-6AF2-14A9-7DBB6FDF686F}"/>
+              </a:ext>
+            </a:extLst>
+          </p:cNvPr>
           <p:cNvSpPr/>
           <p:nvPr/>
         </p:nvSpPr>
         <p:spPr>
           <a:xfrm>
-            <a:off x="1097280" y="4434840"/>
-            <a:ext cx="3154680" cy="1600200"/>
+            <a:off x="1112367" y="5903468"/>
+            <a:ext cx="9966960" cy="36576"/>
           </a:xfrm>
-          <a:prstGeom prst="roundRect">
+          <a:prstGeom prst="rect">
             <a:avLst/>
           </a:prstGeom>
           <a:solidFill>
-            <a:srgbClr val="161E2C"/>
+            <a:srgbClr val="6366F1"/>
           </a:solidFill>
-          <a:ln w="12700">
-            <a:solidFill>
-              <a:srgbClr val="2E3B52"/>
-            </a:solidFill>
+          <a:ln>
+            <a:noFill/>
           </a:ln>
         </p:spPr>
         <p:style>
@@ -3384,243 +3615,7 @@
           <a:lstStyle/>
           <a:p>
             <a:pPr algn="ctr"/>
-          </a:p>
-        </p:txBody>
-      </p:sp>
-      <p:sp>
-        <p:nvSpPr>
-          <p:cNvPr id="9" name="TextBox 8"/>
-          <p:cNvSpPr txBox="1"/>
-          <p:nvPr/>
-        </p:nvSpPr>
-        <p:spPr>
-          <a:xfrm>
-            <a:off x="1280160" y="4572000"/>
-            <a:ext cx="2788920" cy="1325880"/>
-          </a:xfrm>
-          <a:prstGeom prst="rect">
-            <a:avLst/>
-          </a:prstGeom>
-          <a:noFill/>
-        </p:spPr>
-        <p:txBody>
-          <a:bodyPr wrap="square">
-            <a:spAutoFit/>
-          </a:bodyPr>
-          <a:lstStyle/>
-          <a:p>
-            <a:pPr>
-              <a:defRPr sz="1400" b="1">
-                <a:solidFill>
-                  <a:srgbClr val="FFFFFF"/>
-                </a:solidFill>
-                <a:latin typeface="Segoe UI"/>
-              </a:defRPr>
-            </a:pPr>
-            <a:r>
-              <a:t>🪟 Плавающий оверлей</a:t>
-            </a:r>
-          </a:p>
-          <a:p>
-            <a:pPr>
-              <a:defRPr sz="1100">
-                <a:solidFill>
-                  <a:srgbClr val="94A3B8"/>
-                </a:solidFill>
-                <a:latin typeface="Segoe UI"/>
-              </a:defRPr>
-            </a:pPr>
-            <a:r>
-              <a:t>Вызывается по Alt+S поверх любых чатов и окон без переключения контекста</a:t>
-            </a:r>
-          </a:p>
-        </p:txBody>
-      </p:sp>
-      <p:sp>
-        <p:nvSpPr>
-          <p:cNvPr id="10" name="Rounded Rectangle 9"/>
-          <p:cNvSpPr/>
-          <p:nvPr/>
-        </p:nvSpPr>
-        <p:spPr>
-          <a:xfrm>
-            <a:off x="4498848" y="4434840"/>
-            <a:ext cx="3154680" cy="1600200"/>
-          </a:xfrm>
-          <a:prstGeom prst="roundRect">
-            <a:avLst/>
-          </a:prstGeom>
-          <a:solidFill>
-            <a:srgbClr val="161E2C"/>
-          </a:solidFill>
-          <a:ln w="12700">
-            <a:solidFill>
-              <a:srgbClr val="2E3B52"/>
-            </a:solidFill>
-          </a:ln>
-        </p:spPr>
-        <p:style>
-          <a:lnRef idx="1">
-            <a:schemeClr val="accent1"/>
-          </a:lnRef>
-          <a:fillRef idx="3">
-            <a:schemeClr val="accent1"/>
-          </a:fillRef>
-          <a:effectRef idx="2">
-            <a:schemeClr val="accent1"/>
-          </a:effectRef>
-          <a:fontRef idx="minor">
-            <a:schemeClr val="lt1"/>
-          </a:fontRef>
-        </p:style>
-        <p:txBody>
-          <a:bodyPr rtlCol="0" anchor="ctr"/>
-          <a:lstStyle/>
-          <a:p>
-            <a:pPr algn="ctr"/>
-          </a:p>
-        </p:txBody>
-      </p:sp>
-      <p:sp>
-        <p:nvSpPr>
-          <p:cNvPr id="11" name="TextBox 10"/>
-          <p:cNvSpPr txBox="1"/>
-          <p:nvPr/>
-        </p:nvSpPr>
-        <p:spPr>
-          <a:xfrm>
-            <a:off x="4681728" y="4572000"/>
-            <a:ext cx="2788920" cy="1325880"/>
-          </a:xfrm>
-          <a:prstGeom prst="rect">
-            <a:avLst/>
-          </a:prstGeom>
-          <a:noFill/>
-        </p:spPr>
-        <p:txBody>
-          <a:bodyPr wrap="square">
-            <a:spAutoFit/>
-          </a:bodyPr>
-          <a:lstStyle/>
-          <a:p>
-            <a:pPr>
-              <a:defRPr sz="1400" b="1">
-                <a:solidFill>
-                  <a:srgbClr val="FFFFFF"/>
-                </a:solidFill>
-                <a:latin typeface="Segoe UI"/>
-              </a:defRPr>
-            </a:pPr>
-            <a:r>
-              <a:t>🧠 Нейросетевой анализ</a:t>
-            </a:r>
-          </a:p>
-          <a:p>
-            <a:pPr>
-              <a:defRPr sz="1100">
-                <a:solidFill>
-                  <a:srgbClr val="94A3B8"/>
-                </a:solidFill>
-                <a:latin typeface="Segoe UI"/>
-              </a:defRPr>
-            </a:pPr>
-            <a:r>
-              <a:t>Мультимодальное зрение по API: видит реальный интерфейс переписки</a:t>
-            </a:r>
-          </a:p>
-        </p:txBody>
-      </p:sp>
-      <p:sp>
-        <p:nvSpPr>
-          <p:cNvPr id="12" name="Rounded Rectangle 11"/>
-          <p:cNvSpPr/>
-          <p:nvPr/>
-        </p:nvSpPr>
-        <p:spPr>
-          <a:xfrm>
-            <a:off x="7900416" y="4434840"/>
-            <a:ext cx="3154680" cy="1600200"/>
-          </a:xfrm>
-          <a:prstGeom prst="roundRect">
-            <a:avLst/>
-          </a:prstGeom>
-          <a:solidFill>
-            <a:srgbClr val="161E2C"/>
-          </a:solidFill>
-          <a:ln w="12700">
-            <a:solidFill>
-              <a:srgbClr val="2E3B52"/>
-            </a:solidFill>
-          </a:ln>
-        </p:spPr>
-        <p:style>
-          <a:lnRef idx="1">
-            <a:schemeClr val="accent1"/>
-          </a:lnRef>
-          <a:fillRef idx="3">
-            <a:schemeClr val="accent1"/>
-          </a:fillRef>
-          <a:effectRef idx="2">
-            <a:schemeClr val="accent1"/>
-          </a:effectRef>
-          <a:fontRef idx="minor">
-            <a:schemeClr val="lt1"/>
-          </a:fontRef>
-        </p:style>
-        <p:txBody>
-          <a:bodyPr rtlCol="0" anchor="ctr"/>
-          <a:lstStyle/>
-          <a:p>
-            <a:pPr algn="ctr"/>
-          </a:p>
-        </p:txBody>
-      </p:sp>
-      <p:sp>
-        <p:nvSpPr>
-          <p:cNvPr id="13" name="TextBox 12"/>
-          <p:cNvSpPr txBox="1"/>
-          <p:nvPr/>
-        </p:nvSpPr>
-        <p:spPr>
-          <a:xfrm>
-            <a:off x="8083296" y="4572000"/>
-            <a:ext cx="2788920" cy="1325880"/>
-          </a:xfrm>
-          <a:prstGeom prst="rect">
-            <a:avLst/>
-          </a:prstGeom>
-          <a:noFill/>
-        </p:spPr>
-        <p:txBody>
-          <a:bodyPr wrap="square">
-            <a:spAutoFit/>
-          </a:bodyPr>
-          <a:lstStyle/>
-          <a:p>
-            <a:pPr>
-              <a:defRPr sz="1400" b="1">
-                <a:solidFill>
-                  <a:srgbClr val="FFFFFF"/>
-                </a:solidFill>
-                <a:latin typeface="Segoe UI"/>
-              </a:defRPr>
-            </a:pPr>
-            <a:r>
-              <a:t>⚡ Готов к работе (.exe)</a:t>
-            </a:r>
-          </a:p>
-          <a:p>
-            <a:pPr>
-              <a:defRPr sz="1100">
-                <a:solidFill>
-                  <a:srgbClr val="94A3B8"/>
-                </a:solidFill>
-                <a:latin typeface="Segoe UI"/>
-              </a:defRPr>
-            </a:pPr>
-            <a:r>
-              <a:t>Автономный запуск в один клик без установки дополнительного софта</a:t>
-            </a:r>
+            <a:endParaRPr/>
           </a:p>
         </p:txBody>
       </p:sp>
@@ -3633,7 +3628,7 @@
 </file>
 
 <file path=ppt/slides/slide2.xml><?xml version="1.0" encoding="utf-8"?>
-<p:sld xmlns:a="http://schemas.openxmlformats.org/drawingml/2006/main" xmlns:p="http://schemas.openxmlformats.org/presentationml/2006/main" xmlns:r="http://schemas.openxmlformats.org/officeDocument/2006/relationships">
+<p:sld xmlns:a="http://schemas.openxmlformats.org/drawingml/2006/main" xmlns:r="http://schemas.openxmlformats.org/officeDocument/2006/relationships" xmlns:p="http://schemas.openxmlformats.org/presentationml/2006/main">
   <p:cSld>
     <p:spTree>
       <p:nvGrpSpPr>
@@ -3641,7 +3636,14 @@
         <p:cNvGrpSpPr/>
         <p:nvPr/>
       </p:nvGrpSpPr>
-      <p:grpSpPr/>
+      <p:grpSpPr>
+        <a:xfrm>
+          <a:off x="0" y="0"/>
+          <a:ext cx="0" cy="0"/>
+          <a:chOff x="0" y="0"/>
+          <a:chExt cx="0" cy="0"/>
+        </a:xfrm>
+      </p:grpSpPr>
       <p:sp>
         <p:nvSpPr>
           <p:cNvPr id="2" name="Rectangle 1"/>
@@ -3682,6 +3684,7 @@
           <a:lstStyle/>
           <a:p>
             <a:pPr algn="ctr"/>
+            <a:endParaRPr/>
           </a:p>
         </p:txBody>
       </p:sp>
@@ -3723,7 +3726,7 @@
           </a:fontRef>
         </p:style>
         <p:txBody>
-          <a:bodyPr rtlCol="0" anchor="ctr" wrap="square" lIns="0" rIns="0" tIns="0" bIns="0"/>
+          <a:bodyPr wrap="square" lIns="0" tIns="0" rIns="0" bIns="0" rtlCol="0" anchor="ctr"/>
           <a:lstStyle/>
           <a:p>
             <a:pPr algn="ctr">
@@ -3831,6 +3834,7 @@
           <a:lstStyle/>
           <a:p>
             <a:pPr algn="ctr"/>
+            <a:endParaRPr/>
           </a:p>
         </p:txBody>
       </p:sp>
@@ -3842,8 +3846,8 @@
         </p:nvSpPr>
         <p:spPr>
           <a:xfrm>
-            <a:off x="1097280" y="2331720"/>
-            <a:ext cx="91440" cy="3931920"/>
+            <a:off x="1097280" y="2981616"/>
+            <a:ext cx="91440" cy="2673853"/>
           </a:xfrm>
           <a:prstGeom prst="rect">
             <a:avLst/>
@@ -3874,6 +3878,7 @@
           <a:lstStyle/>
           <a:p>
             <a:pPr algn="ctr"/>
+            <a:endParaRPr/>
           </a:p>
         </p:txBody>
       </p:sp>
@@ -3886,7 +3891,7 @@
         <p:spPr>
           <a:xfrm>
             <a:off x="1371600" y="2514600"/>
-            <a:ext cx="4389120" cy="3566160"/>
+            <a:ext cx="4514850" cy="3062377"/>
           </a:xfrm>
           <a:prstGeom prst="rect">
             <a:avLst/>
@@ -3908,8 +3913,30 @@
               </a:defRPr>
             </a:pPr>
             <a:r>
-              <a:t>🛑 Проблема цифрового текста</a:t>
-            </a:r>
+              <a:rPr lang="ru-RU" dirty="0"/>
+              <a:t>	</a:t>
+            </a:r>
+            <a:r>
+              <a:rPr dirty="0" err="1"/>
+              <a:t>Проблема</a:t>
+            </a:r>
+            <a:r>
+              <a:rPr dirty="0"/>
+              <a:t> </a:t>
+            </a:r>
+            <a:r>
+              <a:rPr dirty="0" err="1"/>
+              <a:t>цифрового</a:t>
+            </a:r>
+            <a:r>
+              <a:rPr dirty="0"/>
+              <a:t> </a:t>
+            </a:r>
+            <a:r>
+              <a:rPr dirty="0" err="1"/>
+              <a:t>текста</a:t>
+            </a:r>
+            <a:endParaRPr dirty="0"/>
           </a:p>
           <a:p>
             <a:pPr>
@@ -3918,21 +3945,226 @@
               </a:defRPr>
             </a:pPr>
             <a:r>
-              <a:rPr b="1">
+              <a:rPr sz="1600" b="1" dirty="0">
                 <a:solidFill>
                   <a:srgbClr val="F59E0B"/>
                 </a:solidFill>
               </a:rPr>
-              <a:t>• Скрытая агрессия и сарказм: </a:t>
-            </a:r>
-            <a:r>
-              <a:rPr>
-                <a:solidFill>
-                  <a:srgbClr val="CBD5E1"/>
-                </a:solidFill>
-              </a:rPr>
-              <a:t>пассивный негатив часто прячется за вежливыми фразами — пропустить его легко.</a:t>
-            </a:r>
+              <a:t>• </a:t>
+            </a:r>
+            <a:r>
+              <a:rPr sz="1600" b="1" dirty="0" err="1">
+                <a:solidFill>
+                  <a:srgbClr val="F59E0B"/>
+                </a:solidFill>
+              </a:rPr>
+              <a:t>Скрытая</a:t>
+            </a:r>
+            <a:r>
+              <a:rPr sz="1600" b="1" dirty="0">
+                <a:solidFill>
+                  <a:srgbClr val="F59E0B"/>
+                </a:solidFill>
+              </a:rPr>
+              <a:t> </a:t>
+            </a:r>
+            <a:r>
+              <a:rPr sz="1600" b="1" dirty="0" err="1">
+                <a:solidFill>
+                  <a:srgbClr val="F59E0B"/>
+                </a:solidFill>
+              </a:rPr>
+              <a:t>агрессия</a:t>
+            </a:r>
+            <a:r>
+              <a:rPr sz="1600" b="1" dirty="0">
+                <a:solidFill>
+                  <a:srgbClr val="F59E0B"/>
+                </a:solidFill>
+              </a:rPr>
+              <a:t> и </a:t>
+            </a:r>
+            <a:r>
+              <a:rPr sz="1600" b="1" dirty="0" err="1">
+                <a:solidFill>
+                  <a:srgbClr val="F59E0B"/>
+                </a:solidFill>
+              </a:rPr>
+              <a:t>сарказм</a:t>
+            </a:r>
+            <a:r>
+              <a:rPr sz="1600" b="1" dirty="0">
+                <a:solidFill>
+                  <a:srgbClr val="F59E0B"/>
+                </a:solidFill>
+              </a:rPr>
+              <a:t>: </a:t>
+            </a:r>
+            <a:r>
+              <a:rPr sz="1600" dirty="0" err="1">
+                <a:solidFill>
+                  <a:srgbClr val="CBD5E1"/>
+                </a:solidFill>
+              </a:rPr>
+              <a:t>пассивный</a:t>
+            </a:r>
+            <a:r>
+              <a:rPr sz="1600" dirty="0">
+                <a:solidFill>
+                  <a:srgbClr val="CBD5E1"/>
+                </a:solidFill>
+              </a:rPr>
+              <a:t> </a:t>
+            </a:r>
+            <a:r>
+              <a:rPr sz="1600" dirty="0" err="1">
+                <a:solidFill>
+                  <a:srgbClr val="CBD5E1"/>
+                </a:solidFill>
+              </a:rPr>
+              <a:t>негатив</a:t>
+            </a:r>
+            <a:r>
+              <a:rPr sz="1600" dirty="0">
+                <a:solidFill>
+                  <a:srgbClr val="CBD5E1"/>
+                </a:solidFill>
+              </a:rPr>
+              <a:t> </a:t>
+            </a:r>
+            <a:r>
+              <a:rPr sz="1600" dirty="0" err="1">
+                <a:solidFill>
+                  <a:srgbClr val="CBD5E1"/>
+                </a:solidFill>
+              </a:rPr>
+              <a:t>часто</a:t>
+            </a:r>
+            <a:r>
+              <a:rPr sz="1600" dirty="0">
+                <a:solidFill>
+                  <a:srgbClr val="CBD5E1"/>
+                </a:solidFill>
+              </a:rPr>
+              <a:t> </a:t>
+            </a:r>
+            <a:r>
+              <a:rPr sz="1600" dirty="0" err="1">
+                <a:solidFill>
+                  <a:srgbClr val="CBD5E1"/>
+                </a:solidFill>
+              </a:rPr>
+              <a:t>прячется</a:t>
+            </a:r>
+            <a:r>
+              <a:rPr sz="1600" dirty="0">
+                <a:solidFill>
+                  <a:srgbClr val="CBD5E1"/>
+                </a:solidFill>
+              </a:rPr>
+              <a:t> </a:t>
+            </a:r>
+            <a:r>
+              <a:rPr sz="1600" dirty="0" err="1">
+                <a:solidFill>
+                  <a:srgbClr val="CBD5E1"/>
+                </a:solidFill>
+              </a:rPr>
+              <a:t>за</a:t>
+            </a:r>
+            <a:r>
+              <a:rPr sz="1600" dirty="0">
+                <a:solidFill>
+                  <a:srgbClr val="CBD5E1"/>
+                </a:solidFill>
+              </a:rPr>
+              <a:t> </a:t>
+            </a:r>
+            <a:r>
+              <a:rPr sz="1600" dirty="0" err="1">
+                <a:solidFill>
+                  <a:srgbClr val="CBD5E1"/>
+                </a:solidFill>
+              </a:rPr>
+              <a:t>вежливыми</a:t>
+            </a:r>
+            <a:r>
+              <a:rPr sz="1600" dirty="0">
+                <a:solidFill>
+                  <a:srgbClr val="CBD5E1"/>
+                </a:solidFill>
+              </a:rPr>
+              <a:t> </a:t>
+            </a:r>
+            <a:r>
+              <a:rPr sz="1600" dirty="0" err="1">
+                <a:solidFill>
+                  <a:srgbClr val="CBD5E1"/>
+                </a:solidFill>
+              </a:rPr>
+              <a:t>фразами</a:t>
+            </a:r>
+            <a:r>
+              <a:rPr sz="1600" dirty="0">
+                <a:solidFill>
+                  <a:srgbClr val="CBD5E1"/>
+                </a:solidFill>
+              </a:rPr>
+              <a:t> — </a:t>
+            </a:r>
+            <a:r>
+              <a:rPr sz="1600" dirty="0" err="1">
+                <a:solidFill>
+                  <a:srgbClr val="CBD5E1"/>
+                </a:solidFill>
+              </a:rPr>
+              <a:t>пропустить</a:t>
+            </a:r>
+            <a:r>
+              <a:rPr sz="1600" dirty="0">
+                <a:solidFill>
+                  <a:srgbClr val="CBD5E1"/>
+                </a:solidFill>
+              </a:rPr>
+              <a:t> </a:t>
+            </a:r>
+            <a:r>
+              <a:rPr sz="1600" dirty="0" err="1">
+                <a:solidFill>
+                  <a:srgbClr val="CBD5E1"/>
+                </a:solidFill>
+              </a:rPr>
+              <a:t>его</a:t>
+            </a:r>
+            <a:r>
+              <a:rPr sz="1600" dirty="0">
+                <a:solidFill>
+                  <a:srgbClr val="CBD5E1"/>
+                </a:solidFill>
+              </a:rPr>
+              <a:t> </a:t>
+            </a:r>
+            <a:r>
+              <a:rPr sz="1600" dirty="0" err="1">
+                <a:solidFill>
+                  <a:srgbClr val="CBD5E1"/>
+                </a:solidFill>
+              </a:rPr>
+              <a:t>легко</a:t>
+            </a:r>
+            <a:r>
+              <a:rPr sz="1600" dirty="0">
+                <a:solidFill>
+                  <a:srgbClr val="CBD5E1"/>
+                </a:solidFill>
+              </a:rPr>
+              <a:t>.</a:t>
+            </a:r>
+            <a:endParaRPr lang="ru-RU" sz="1600" dirty="0">
+              <a:solidFill>
+                <a:srgbClr val="CBD5E1"/>
+              </a:solidFill>
+            </a:endParaRPr>
           </a:p>
           <a:p>
             <a:pPr>
@@ -3940,22 +4172,11 @@
                 <a:latin typeface="Segoe UI"/>
               </a:defRPr>
             </a:pPr>
-            <a:r>
-              <a:rPr b="1">
-                <a:solidFill>
-                  <a:srgbClr val="F59E0B"/>
-                </a:solidFill>
-              </a:rPr>
-              <a:t>• Цена ошибки в один ответ: </a:t>
-            </a:r>
-            <a:r>
-              <a:rPr>
-                <a:solidFill>
-                  <a:srgbClr val="CBD5E1"/>
-                </a:solidFill>
-              </a:rPr>
-              <a:t>сорванная сделка на Авито/FunPay, конфликт с клиентом или ссора в рабочем чате.</a:t>
-            </a:r>
+            <a:endParaRPr sz="1600" dirty="0">
+              <a:solidFill>
+                <a:srgbClr val="CBD5E1"/>
+              </a:solidFill>
+            </a:endParaRPr>
           </a:p>
           <a:p>
             <a:pPr>
@@ -3964,20 +4185,492 @@
               </a:defRPr>
             </a:pPr>
             <a:r>
-              <a:rPr b="1">
+              <a:rPr sz="1600" b="1" dirty="0">
                 <a:solidFill>
                   <a:srgbClr val="F59E0B"/>
                 </a:solidFill>
               </a:rPr>
-              <a:t>• Ступор формулировок: </a:t>
-            </a:r>
-            <a:r>
-              <a:rPr>
-                <a:solidFill>
-                  <a:srgbClr val="CBD5E1"/>
-                </a:solidFill>
-              </a:rPr>
-              <a:t>поиск ответа отнимает десятки минут: «как отказать без обид?», «как поторговаться?».</a:t>
+              <a:t>• </a:t>
+            </a:r>
+            <a:r>
+              <a:rPr sz="1600" b="1" dirty="0" err="1">
+                <a:solidFill>
+                  <a:srgbClr val="F59E0B"/>
+                </a:solidFill>
+              </a:rPr>
+              <a:t>Цена</a:t>
+            </a:r>
+            <a:r>
+              <a:rPr sz="1600" b="1" dirty="0">
+                <a:solidFill>
+                  <a:srgbClr val="F59E0B"/>
+                </a:solidFill>
+              </a:rPr>
+              <a:t> </a:t>
+            </a:r>
+            <a:r>
+              <a:rPr sz="1600" b="1" dirty="0" err="1">
+                <a:solidFill>
+                  <a:srgbClr val="F59E0B"/>
+                </a:solidFill>
+              </a:rPr>
+              <a:t>ошибки</a:t>
+            </a:r>
+            <a:r>
+              <a:rPr sz="1600" b="1" dirty="0">
+                <a:solidFill>
+                  <a:srgbClr val="F59E0B"/>
+                </a:solidFill>
+              </a:rPr>
+              <a:t> в </a:t>
+            </a:r>
+            <a:r>
+              <a:rPr sz="1600" b="1" dirty="0" err="1">
+                <a:solidFill>
+                  <a:srgbClr val="F59E0B"/>
+                </a:solidFill>
+              </a:rPr>
+              <a:t>один</a:t>
+            </a:r>
+            <a:r>
+              <a:rPr sz="1600" b="1" dirty="0">
+                <a:solidFill>
+                  <a:srgbClr val="F59E0B"/>
+                </a:solidFill>
+              </a:rPr>
+              <a:t> </a:t>
+            </a:r>
+            <a:r>
+              <a:rPr sz="1600" b="1" dirty="0" err="1">
+                <a:solidFill>
+                  <a:srgbClr val="F59E0B"/>
+                </a:solidFill>
+              </a:rPr>
+              <a:t>ответ</a:t>
+            </a:r>
+            <a:r>
+              <a:rPr sz="1600" b="1" dirty="0">
+                <a:solidFill>
+                  <a:srgbClr val="F59E0B"/>
+                </a:solidFill>
+              </a:rPr>
+              <a:t>: </a:t>
+            </a:r>
+            <a:r>
+              <a:rPr sz="1600" dirty="0" err="1">
+                <a:solidFill>
+                  <a:srgbClr val="CBD5E1"/>
+                </a:solidFill>
+              </a:rPr>
+              <a:t>сорванная</a:t>
+            </a:r>
+            <a:r>
+              <a:rPr sz="1600" dirty="0">
+                <a:solidFill>
+                  <a:srgbClr val="CBD5E1"/>
+                </a:solidFill>
+              </a:rPr>
+              <a:t> </a:t>
+            </a:r>
+            <a:r>
+              <a:rPr sz="1600" dirty="0" err="1">
+                <a:solidFill>
+                  <a:srgbClr val="CBD5E1"/>
+                </a:solidFill>
+              </a:rPr>
+              <a:t>сделка</a:t>
+            </a:r>
+            <a:r>
+              <a:rPr sz="1600" dirty="0">
+                <a:solidFill>
+                  <a:srgbClr val="CBD5E1"/>
+                </a:solidFill>
+              </a:rPr>
+              <a:t> </a:t>
+            </a:r>
+            <a:r>
+              <a:rPr sz="1600" dirty="0" err="1">
+                <a:solidFill>
+                  <a:srgbClr val="CBD5E1"/>
+                </a:solidFill>
+              </a:rPr>
+              <a:t>на</a:t>
+            </a:r>
+            <a:r>
+              <a:rPr sz="1600" dirty="0">
+                <a:solidFill>
+                  <a:srgbClr val="CBD5E1"/>
+                </a:solidFill>
+              </a:rPr>
+              <a:t> </a:t>
+            </a:r>
+            <a:r>
+              <a:rPr sz="1600" dirty="0" err="1">
+                <a:solidFill>
+                  <a:srgbClr val="CBD5E1"/>
+                </a:solidFill>
+              </a:rPr>
+              <a:t>Авито</a:t>
+            </a:r>
+            <a:r>
+              <a:rPr sz="1600" dirty="0">
+                <a:solidFill>
+                  <a:srgbClr val="CBD5E1"/>
+                </a:solidFill>
+              </a:rPr>
+              <a:t>/</a:t>
+            </a:r>
+            <a:r>
+              <a:rPr sz="1600" dirty="0" err="1">
+                <a:solidFill>
+                  <a:srgbClr val="CBD5E1"/>
+                </a:solidFill>
+              </a:rPr>
+              <a:t>FunPay</a:t>
+            </a:r>
+            <a:r>
+              <a:rPr sz="1600" dirty="0">
+                <a:solidFill>
+                  <a:srgbClr val="CBD5E1"/>
+                </a:solidFill>
+              </a:rPr>
+              <a:t>, </a:t>
+            </a:r>
+            <a:r>
+              <a:rPr sz="1600" dirty="0" err="1">
+                <a:solidFill>
+                  <a:srgbClr val="CBD5E1"/>
+                </a:solidFill>
+              </a:rPr>
+              <a:t>конфликт</a:t>
+            </a:r>
+            <a:r>
+              <a:rPr sz="1600" dirty="0">
+                <a:solidFill>
+                  <a:srgbClr val="CBD5E1"/>
+                </a:solidFill>
+              </a:rPr>
+              <a:t> с </a:t>
+            </a:r>
+            <a:r>
+              <a:rPr sz="1600" dirty="0" err="1">
+                <a:solidFill>
+                  <a:srgbClr val="CBD5E1"/>
+                </a:solidFill>
+              </a:rPr>
+              <a:t>клиентом</a:t>
+            </a:r>
+            <a:r>
+              <a:rPr sz="1600" dirty="0">
+                <a:solidFill>
+                  <a:srgbClr val="CBD5E1"/>
+                </a:solidFill>
+              </a:rPr>
+              <a:t> </a:t>
+            </a:r>
+            <a:r>
+              <a:rPr sz="1600" dirty="0" err="1">
+                <a:solidFill>
+                  <a:srgbClr val="CBD5E1"/>
+                </a:solidFill>
+              </a:rPr>
+              <a:t>или</a:t>
+            </a:r>
+            <a:r>
+              <a:rPr sz="1600" dirty="0">
+                <a:solidFill>
+                  <a:srgbClr val="CBD5E1"/>
+                </a:solidFill>
+              </a:rPr>
+              <a:t> </a:t>
+            </a:r>
+            <a:r>
+              <a:rPr sz="1600" dirty="0" err="1">
+                <a:solidFill>
+                  <a:srgbClr val="CBD5E1"/>
+                </a:solidFill>
+              </a:rPr>
+              <a:t>ссора</a:t>
+            </a:r>
+            <a:r>
+              <a:rPr sz="1600" dirty="0">
+                <a:solidFill>
+                  <a:srgbClr val="CBD5E1"/>
+                </a:solidFill>
+              </a:rPr>
+              <a:t> в </a:t>
+            </a:r>
+            <a:r>
+              <a:rPr sz="1600" dirty="0" err="1">
+                <a:solidFill>
+                  <a:srgbClr val="CBD5E1"/>
+                </a:solidFill>
+              </a:rPr>
+              <a:t>рабочем</a:t>
+            </a:r>
+            <a:r>
+              <a:rPr sz="1600" dirty="0">
+                <a:solidFill>
+                  <a:srgbClr val="CBD5E1"/>
+                </a:solidFill>
+              </a:rPr>
+              <a:t> </a:t>
+            </a:r>
+            <a:r>
+              <a:rPr sz="1600" dirty="0" err="1">
+                <a:solidFill>
+                  <a:srgbClr val="CBD5E1"/>
+                </a:solidFill>
+              </a:rPr>
+              <a:t>чате</a:t>
+            </a:r>
+            <a:r>
+              <a:rPr sz="1600" dirty="0">
+                <a:solidFill>
+                  <a:srgbClr val="CBD5E1"/>
+                </a:solidFill>
+              </a:rPr>
+              <a:t>.</a:t>
+            </a:r>
+            <a:endParaRPr lang="ru-RU" sz="1600" dirty="0">
+              <a:solidFill>
+                <a:srgbClr val="CBD5E1"/>
+              </a:solidFill>
+            </a:endParaRPr>
+          </a:p>
+          <a:p>
+            <a:pPr>
+              <a:defRPr sz="1200">
+                <a:latin typeface="Segoe UI"/>
+              </a:defRPr>
+            </a:pPr>
+            <a:endParaRPr sz="1600" dirty="0">
+              <a:solidFill>
+                <a:srgbClr val="CBD5E1"/>
+              </a:solidFill>
+            </a:endParaRPr>
+          </a:p>
+          <a:p>
+            <a:pPr>
+              <a:defRPr sz="1200">
+                <a:latin typeface="Segoe UI"/>
+              </a:defRPr>
+            </a:pPr>
+            <a:r>
+              <a:rPr sz="1600" b="1" dirty="0">
+                <a:solidFill>
+                  <a:srgbClr val="F59E0B"/>
+                </a:solidFill>
+              </a:rPr>
+              <a:t>• </a:t>
+            </a:r>
+            <a:r>
+              <a:rPr sz="1600" b="1" dirty="0" err="1">
+                <a:solidFill>
+                  <a:srgbClr val="F59E0B"/>
+                </a:solidFill>
+              </a:rPr>
+              <a:t>Ступор</a:t>
+            </a:r>
+            <a:r>
+              <a:rPr sz="1600" b="1" dirty="0">
+                <a:solidFill>
+                  <a:srgbClr val="F59E0B"/>
+                </a:solidFill>
+              </a:rPr>
+              <a:t> </a:t>
+            </a:r>
+            <a:r>
+              <a:rPr sz="1600" b="1" dirty="0" err="1">
+                <a:solidFill>
+                  <a:srgbClr val="F59E0B"/>
+                </a:solidFill>
+              </a:rPr>
+              <a:t>формулировок</a:t>
+            </a:r>
+            <a:r>
+              <a:rPr sz="1600" b="1" dirty="0">
+                <a:solidFill>
+                  <a:srgbClr val="F59E0B"/>
+                </a:solidFill>
+              </a:rPr>
+              <a:t>: </a:t>
+            </a:r>
+            <a:r>
+              <a:rPr sz="1600" dirty="0" err="1">
+                <a:solidFill>
+                  <a:srgbClr val="CBD5E1"/>
+                </a:solidFill>
+              </a:rPr>
+              <a:t>поиск</a:t>
+            </a:r>
+            <a:r>
+              <a:rPr sz="1600" dirty="0">
+                <a:solidFill>
+                  <a:srgbClr val="CBD5E1"/>
+                </a:solidFill>
+              </a:rPr>
+              <a:t> </a:t>
+            </a:r>
+            <a:r>
+              <a:rPr sz="1600" dirty="0" err="1">
+                <a:solidFill>
+                  <a:srgbClr val="CBD5E1"/>
+                </a:solidFill>
+              </a:rPr>
+              <a:t>ответа</a:t>
+            </a:r>
+            <a:r>
+              <a:rPr sz="1600" dirty="0">
+                <a:solidFill>
+                  <a:srgbClr val="CBD5E1"/>
+                </a:solidFill>
+              </a:rPr>
+              <a:t> </a:t>
+            </a:r>
+            <a:r>
+              <a:rPr sz="1600" dirty="0" err="1">
+                <a:solidFill>
+                  <a:srgbClr val="CBD5E1"/>
+                </a:solidFill>
+              </a:rPr>
+              <a:t>отнимает</a:t>
+            </a:r>
+            <a:r>
+              <a:rPr sz="1600" dirty="0">
+                <a:solidFill>
+                  <a:srgbClr val="CBD5E1"/>
+                </a:solidFill>
+              </a:rPr>
+              <a:t> </a:t>
+            </a:r>
+            <a:r>
+              <a:rPr sz="1600" dirty="0" err="1">
+                <a:solidFill>
+                  <a:srgbClr val="CBD5E1"/>
+                </a:solidFill>
+              </a:rPr>
+              <a:t>десятки</a:t>
+            </a:r>
+            <a:r>
+              <a:rPr sz="1600" dirty="0">
+                <a:solidFill>
+                  <a:srgbClr val="CBD5E1"/>
+                </a:solidFill>
+              </a:rPr>
+              <a:t> </a:t>
+            </a:r>
+            <a:r>
+              <a:rPr sz="1600" dirty="0" err="1">
+                <a:solidFill>
+                  <a:srgbClr val="CBD5E1"/>
+                </a:solidFill>
+              </a:rPr>
+              <a:t>минут</a:t>
+            </a:r>
+            <a:r>
+              <a:rPr sz="1600" dirty="0">
+                <a:solidFill>
+                  <a:srgbClr val="CBD5E1"/>
+                </a:solidFill>
+              </a:rPr>
+              <a:t>: «</a:t>
+            </a:r>
+            <a:r>
+              <a:rPr sz="1600" dirty="0" err="1">
+                <a:solidFill>
+                  <a:srgbClr val="CBD5E1"/>
+                </a:solidFill>
+              </a:rPr>
+              <a:t>как</a:t>
+            </a:r>
+            <a:r>
+              <a:rPr sz="1600" dirty="0">
+                <a:solidFill>
+                  <a:srgbClr val="CBD5E1"/>
+                </a:solidFill>
+              </a:rPr>
+              <a:t> </a:t>
+            </a:r>
+            <a:r>
+              <a:rPr sz="1600" dirty="0" err="1">
+                <a:solidFill>
+                  <a:srgbClr val="CBD5E1"/>
+                </a:solidFill>
+              </a:rPr>
+              <a:t>отказать</a:t>
+            </a:r>
+            <a:r>
+              <a:rPr sz="1600" dirty="0">
+                <a:solidFill>
+                  <a:srgbClr val="CBD5E1"/>
+                </a:solidFill>
+              </a:rPr>
+              <a:t> </a:t>
+            </a:r>
+            <a:r>
+              <a:rPr sz="1600" dirty="0" err="1">
+                <a:solidFill>
+                  <a:srgbClr val="CBD5E1"/>
+                </a:solidFill>
+              </a:rPr>
+              <a:t>без</a:t>
+            </a:r>
+            <a:r>
+              <a:rPr sz="1600" dirty="0">
+                <a:solidFill>
+                  <a:srgbClr val="CBD5E1"/>
+                </a:solidFill>
+              </a:rPr>
+              <a:t> </a:t>
+            </a:r>
+            <a:r>
+              <a:rPr sz="1600" dirty="0" err="1">
+                <a:solidFill>
+                  <a:srgbClr val="CBD5E1"/>
+                </a:solidFill>
+              </a:rPr>
+              <a:t>обид</a:t>
+            </a:r>
+            <a:r>
+              <a:rPr sz="1600" dirty="0">
+                <a:solidFill>
+                  <a:srgbClr val="CBD5E1"/>
+                </a:solidFill>
+              </a:rPr>
+              <a:t>?», «</a:t>
+            </a:r>
+            <a:r>
+              <a:rPr sz="1600" dirty="0" err="1">
+                <a:solidFill>
+                  <a:srgbClr val="CBD5E1"/>
+                </a:solidFill>
+              </a:rPr>
+              <a:t>как</a:t>
+            </a:r>
+            <a:r>
+              <a:rPr sz="1600" dirty="0">
+                <a:solidFill>
+                  <a:srgbClr val="CBD5E1"/>
+                </a:solidFill>
+              </a:rPr>
+              <a:t> </a:t>
+            </a:r>
+            <a:r>
+              <a:rPr sz="1600" dirty="0" err="1">
+                <a:solidFill>
+                  <a:srgbClr val="CBD5E1"/>
+                </a:solidFill>
+              </a:rPr>
+              <a:t>поторговаться</a:t>
+            </a:r>
+            <a:r>
+              <a:rPr sz="1600" dirty="0">
+                <a:solidFill>
+                  <a:srgbClr val="CBD5E1"/>
+                </a:solidFill>
+              </a:rPr>
+              <a:t>?».</a:t>
             </a:r>
           </a:p>
         </p:txBody>
@@ -4024,6 +4717,7 @@
           <a:lstStyle/>
           <a:p>
             <a:pPr algn="ctr"/>
+            <a:endParaRPr/>
           </a:p>
         </p:txBody>
       </p:sp>
@@ -4035,8 +4729,8 @@
         </p:nvSpPr>
         <p:spPr>
           <a:xfrm>
-            <a:off x="6217920" y="2331720"/>
-            <a:ext cx="91440" cy="3931920"/>
+            <a:off x="6217920" y="2981617"/>
+            <a:ext cx="91440" cy="2673852"/>
           </a:xfrm>
           <a:prstGeom prst="rect">
             <a:avLst/>
@@ -4067,6 +4761,7 @@
           <a:lstStyle/>
           <a:p>
             <a:pPr algn="ctr"/>
+            <a:endParaRPr/>
           </a:p>
         </p:txBody>
       </p:sp>
@@ -4079,7 +4774,7 @@
         <p:spPr>
           <a:xfrm>
             <a:off x="6492240" y="2514600"/>
-            <a:ext cx="4389120" cy="3566160"/>
+            <a:ext cx="4389120" cy="3062377"/>
           </a:xfrm>
           <a:prstGeom prst="rect">
             <a:avLst/>
@@ -4101,7 +4796,32 @@
               </a:defRPr>
             </a:pPr>
             <a:r>
-              <a:t>✨ Идея решения: VibeSense AI</a:t>
+              <a:rPr lang="ru-RU" dirty="0"/>
+              <a:t>	</a:t>
+            </a:r>
+            <a:r>
+              <a:rPr dirty="0" err="1"/>
+              <a:t>Идея</a:t>
+            </a:r>
+            <a:r>
+              <a:rPr dirty="0"/>
+              <a:t> </a:t>
+            </a:r>
+            <a:r>
+              <a:rPr dirty="0" err="1"/>
+              <a:t>решения</a:t>
+            </a:r>
+            <a:r>
+              <a:rPr dirty="0"/>
+              <a:t>: </a:t>
+            </a:r>
+            <a:r>
+              <a:rPr dirty="0" err="1"/>
+              <a:t>VibeSense</a:t>
+            </a:r>
+            <a:r>
+              <a:rPr dirty="0"/>
+              <a:t> AI</a:t>
             </a:r>
           </a:p>
           <a:p>
@@ -4111,21 +4831,226 @@
               </a:defRPr>
             </a:pPr>
             <a:r>
-              <a:rPr b="1">
+              <a:rPr sz="1600" b="1" dirty="0">
                 <a:solidFill>
                   <a:srgbClr val="10B981"/>
                 </a:solidFill>
               </a:rPr>
-              <a:t>• «Чувствует» живой контекст: </a:t>
-            </a:r>
-            <a:r>
-              <a:rPr>
-                <a:solidFill>
-                  <a:srgbClr val="CBD5E1"/>
-                </a:solidFill>
-              </a:rPr>
-              <a:t>анализирует скриншот чата (таймстампы, паузы, реакции, эмодзи), а не сухой текст.</a:t>
-            </a:r>
+              <a:t>• «</a:t>
+            </a:r>
+            <a:r>
+              <a:rPr sz="1600" b="1" dirty="0" err="1">
+                <a:solidFill>
+                  <a:srgbClr val="10B981"/>
+                </a:solidFill>
+              </a:rPr>
+              <a:t>Чувствует</a:t>
+            </a:r>
+            <a:r>
+              <a:rPr sz="1600" b="1" dirty="0">
+                <a:solidFill>
+                  <a:srgbClr val="10B981"/>
+                </a:solidFill>
+              </a:rPr>
+              <a:t>» </a:t>
+            </a:r>
+            <a:r>
+              <a:rPr sz="1600" b="1" dirty="0" err="1">
+                <a:solidFill>
+                  <a:srgbClr val="10B981"/>
+                </a:solidFill>
+              </a:rPr>
+              <a:t>живой</a:t>
+            </a:r>
+            <a:r>
+              <a:rPr sz="1600" b="1" dirty="0">
+                <a:solidFill>
+                  <a:srgbClr val="10B981"/>
+                </a:solidFill>
+              </a:rPr>
+              <a:t> </a:t>
+            </a:r>
+            <a:r>
+              <a:rPr sz="1600" b="1" dirty="0" err="1">
+                <a:solidFill>
+                  <a:srgbClr val="10B981"/>
+                </a:solidFill>
+              </a:rPr>
+              <a:t>контекст</a:t>
+            </a:r>
+            <a:r>
+              <a:rPr sz="1600" b="1" dirty="0">
+                <a:solidFill>
+                  <a:srgbClr val="10B981"/>
+                </a:solidFill>
+              </a:rPr>
+              <a:t>: </a:t>
+            </a:r>
+            <a:r>
+              <a:rPr sz="1600" dirty="0" err="1">
+                <a:solidFill>
+                  <a:srgbClr val="CBD5E1"/>
+                </a:solidFill>
+              </a:rPr>
+              <a:t>анализирует</a:t>
+            </a:r>
+            <a:r>
+              <a:rPr sz="1600" dirty="0">
+                <a:solidFill>
+                  <a:srgbClr val="CBD5E1"/>
+                </a:solidFill>
+              </a:rPr>
+              <a:t> </a:t>
+            </a:r>
+            <a:r>
+              <a:rPr sz="1600" dirty="0" err="1">
+                <a:solidFill>
+                  <a:srgbClr val="CBD5E1"/>
+                </a:solidFill>
+              </a:rPr>
+              <a:t>скриншот</a:t>
+            </a:r>
+            <a:r>
+              <a:rPr sz="1600" dirty="0">
+                <a:solidFill>
+                  <a:srgbClr val="CBD5E1"/>
+                </a:solidFill>
+              </a:rPr>
+              <a:t> </a:t>
+            </a:r>
+            <a:r>
+              <a:rPr sz="1600" dirty="0" err="1">
+                <a:solidFill>
+                  <a:srgbClr val="CBD5E1"/>
+                </a:solidFill>
+              </a:rPr>
+              <a:t>чата</a:t>
+            </a:r>
+            <a:r>
+              <a:rPr sz="1600" dirty="0">
+                <a:solidFill>
+                  <a:srgbClr val="CBD5E1"/>
+                </a:solidFill>
+              </a:rPr>
+              <a:t> (</a:t>
+            </a:r>
+            <a:r>
+              <a:rPr sz="1600" dirty="0" err="1">
+                <a:solidFill>
+                  <a:srgbClr val="CBD5E1"/>
+                </a:solidFill>
+              </a:rPr>
+              <a:t>таймстампы</a:t>
+            </a:r>
+            <a:r>
+              <a:rPr sz="1600" dirty="0">
+                <a:solidFill>
+                  <a:srgbClr val="CBD5E1"/>
+                </a:solidFill>
+              </a:rPr>
+              <a:t>, </a:t>
+            </a:r>
+            <a:r>
+              <a:rPr sz="1600" dirty="0" err="1">
+                <a:solidFill>
+                  <a:srgbClr val="CBD5E1"/>
+                </a:solidFill>
+              </a:rPr>
+              <a:t>паузы</a:t>
+            </a:r>
+            <a:r>
+              <a:rPr sz="1600" dirty="0">
+                <a:solidFill>
+                  <a:srgbClr val="CBD5E1"/>
+                </a:solidFill>
+              </a:rPr>
+              <a:t>, </a:t>
+            </a:r>
+            <a:r>
+              <a:rPr sz="1600" dirty="0" err="1">
+                <a:solidFill>
+                  <a:srgbClr val="CBD5E1"/>
+                </a:solidFill>
+              </a:rPr>
+              <a:t>реакции</a:t>
+            </a:r>
+            <a:r>
+              <a:rPr sz="1600" dirty="0">
+                <a:solidFill>
+                  <a:srgbClr val="CBD5E1"/>
+                </a:solidFill>
+              </a:rPr>
+              <a:t>, </a:t>
+            </a:r>
+            <a:r>
+              <a:rPr sz="1600" dirty="0" err="1">
+                <a:solidFill>
+                  <a:srgbClr val="CBD5E1"/>
+                </a:solidFill>
+              </a:rPr>
+              <a:t>эмодзи</a:t>
+            </a:r>
+            <a:r>
+              <a:rPr sz="1600" dirty="0">
+                <a:solidFill>
+                  <a:srgbClr val="CBD5E1"/>
+                </a:solidFill>
+              </a:rPr>
+              <a:t>), а </a:t>
+            </a:r>
+            <a:r>
+              <a:rPr sz="1600" dirty="0" err="1">
+                <a:solidFill>
+                  <a:srgbClr val="CBD5E1"/>
+                </a:solidFill>
+              </a:rPr>
+              <a:t>не</a:t>
+            </a:r>
+            <a:r>
+              <a:rPr sz="1600" dirty="0">
+                <a:solidFill>
+                  <a:srgbClr val="CBD5E1"/>
+                </a:solidFill>
+              </a:rPr>
+              <a:t> </a:t>
+            </a:r>
+            <a:r>
+              <a:rPr sz="1600" dirty="0" err="1">
+                <a:solidFill>
+                  <a:srgbClr val="CBD5E1"/>
+                </a:solidFill>
+              </a:rPr>
+              <a:t>сухой</a:t>
+            </a:r>
+            <a:r>
+              <a:rPr sz="1600" dirty="0">
+                <a:solidFill>
+                  <a:srgbClr val="CBD5E1"/>
+                </a:solidFill>
+              </a:rPr>
+              <a:t> </a:t>
+            </a:r>
+            <a:r>
+              <a:rPr sz="1600" dirty="0" err="1">
+                <a:solidFill>
+                  <a:srgbClr val="CBD5E1"/>
+                </a:solidFill>
+              </a:rPr>
+              <a:t>текст</a:t>
+            </a:r>
+            <a:r>
+              <a:rPr sz="1600" dirty="0">
+                <a:solidFill>
+                  <a:srgbClr val="CBD5E1"/>
+                </a:solidFill>
+              </a:rPr>
+              <a:t>.</a:t>
+            </a:r>
+            <a:endParaRPr lang="ru-RU" sz="1600" dirty="0">
+              <a:solidFill>
+                <a:srgbClr val="CBD5E1"/>
+              </a:solidFill>
+            </a:endParaRPr>
           </a:p>
           <a:p>
             <a:pPr>
@@ -4133,22 +5058,11 @@
                 <a:latin typeface="Segoe UI"/>
               </a:defRPr>
             </a:pPr>
-            <a:r>
-              <a:rPr b="1">
-                <a:solidFill>
-                  <a:srgbClr val="10B981"/>
-                </a:solidFill>
-              </a:rPr>
-              <a:t>• Оцифровывает атмосферу: </a:t>
-            </a:r>
-            <a:r>
-              <a:rPr>
-                <a:solidFill>
-                  <a:srgbClr val="CBD5E1"/>
-                </a:solidFill>
-              </a:rPr>
-              <a:t>шкала накала (1–10), уровень формальности и негласные правила именно этого чата.</a:t>
-            </a:r>
+            <a:endParaRPr sz="1600" dirty="0">
+              <a:solidFill>
+                <a:srgbClr val="CBD5E1"/>
+              </a:solidFill>
+            </a:endParaRPr>
           </a:p>
           <a:p>
             <a:pPr>
@@ -4157,20 +5071,436 @@
               </a:defRPr>
             </a:pPr>
             <a:r>
-              <a:rPr b="1">
+              <a:rPr sz="1600" b="1" dirty="0">
                 <a:solidFill>
                   <a:srgbClr val="10B981"/>
                 </a:solidFill>
               </a:rPr>
-              <a:t>• Помогает в любых сферах: </a:t>
-            </a:r>
-            <a:r>
-              <a:rPr>
-                <a:solidFill>
-                  <a:srgbClr val="CBD5E1"/>
-                </a:solidFill>
-              </a:rPr>
-              <a:t>P2P-торговля (сбить цену), рабочие чаты (снять накал), дейтинг и защита личных границ.</a:t>
+              <a:t>• </a:t>
+            </a:r>
+            <a:r>
+              <a:rPr sz="1600" b="1" dirty="0" err="1">
+                <a:solidFill>
+                  <a:srgbClr val="10B981"/>
+                </a:solidFill>
+              </a:rPr>
+              <a:t>Оцифровывает</a:t>
+            </a:r>
+            <a:r>
+              <a:rPr sz="1600" b="1" dirty="0">
+                <a:solidFill>
+                  <a:srgbClr val="10B981"/>
+                </a:solidFill>
+              </a:rPr>
+              <a:t> </a:t>
+            </a:r>
+            <a:r>
+              <a:rPr sz="1600" b="1" dirty="0" err="1">
+                <a:solidFill>
+                  <a:srgbClr val="10B981"/>
+                </a:solidFill>
+              </a:rPr>
+              <a:t>атмосферу</a:t>
+            </a:r>
+            <a:r>
+              <a:rPr sz="1600" b="1" dirty="0">
+                <a:solidFill>
+                  <a:srgbClr val="10B981"/>
+                </a:solidFill>
+              </a:rPr>
+              <a:t>: </a:t>
+            </a:r>
+            <a:r>
+              <a:rPr sz="1600" dirty="0" err="1">
+                <a:solidFill>
+                  <a:srgbClr val="CBD5E1"/>
+                </a:solidFill>
+              </a:rPr>
+              <a:t>шкала</a:t>
+            </a:r>
+            <a:r>
+              <a:rPr sz="1600" dirty="0">
+                <a:solidFill>
+                  <a:srgbClr val="CBD5E1"/>
+                </a:solidFill>
+              </a:rPr>
+              <a:t> </a:t>
+            </a:r>
+            <a:r>
+              <a:rPr sz="1600" dirty="0" err="1">
+                <a:solidFill>
+                  <a:srgbClr val="CBD5E1"/>
+                </a:solidFill>
+              </a:rPr>
+              <a:t>накала</a:t>
+            </a:r>
+            <a:r>
+              <a:rPr sz="1600" dirty="0">
+                <a:solidFill>
+                  <a:srgbClr val="CBD5E1"/>
+                </a:solidFill>
+              </a:rPr>
+              <a:t> (1–10), </a:t>
+            </a:r>
+            <a:r>
+              <a:rPr sz="1600" dirty="0" err="1">
+                <a:solidFill>
+                  <a:srgbClr val="CBD5E1"/>
+                </a:solidFill>
+              </a:rPr>
+              <a:t>уровень</a:t>
+            </a:r>
+            <a:r>
+              <a:rPr sz="1600" dirty="0">
+                <a:solidFill>
+                  <a:srgbClr val="CBD5E1"/>
+                </a:solidFill>
+              </a:rPr>
+              <a:t> </a:t>
+            </a:r>
+            <a:r>
+              <a:rPr sz="1600" dirty="0" err="1">
+                <a:solidFill>
+                  <a:srgbClr val="CBD5E1"/>
+                </a:solidFill>
+              </a:rPr>
+              <a:t>формальности</a:t>
+            </a:r>
+            <a:r>
+              <a:rPr sz="1600" dirty="0">
+                <a:solidFill>
+                  <a:srgbClr val="CBD5E1"/>
+                </a:solidFill>
+              </a:rPr>
+              <a:t> и </a:t>
+            </a:r>
+            <a:r>
+              <a:rPr sz="1600" dirty="0" err="1">
+                <a:solidFill>
+                  <a:srgbClr val="CBD5E1"/>
+                </a:solidFill>
+              </a:rPr>
+              <a:t>негласные</a:t>
+            </a:r>
+            <a:r>
+              <a:rPr sz="1600" dirty="0">
+                <a:solidFill>
+                  <a:srgbClr val="CBD5E1"/>
+                </a:solidFill>
+              </a:rPr>
+              <a:t> </a:t>
+            </a:r>
+            <a:r>
+              <a:rPr sz="1600" dirty="0" err="1">
+                <a:solidFill>
+                  <a:srgbClr val="CBD5E1"/>
+                </a:solidFill>
+              </a:rPr>
+              <a:t>правила</a:t>
+            </a:r>
+            <a:r>
+              <a:rPr sz="1600" dirty="0">
+                <a:solidFill>
+                  <a:srgbClr val="CBD5E1"/>
+                </a:solidFill>
+              </a:rPr>
+              <a:t> </a:t>
+            </a:r>
+            <a:r>
+              <a:rPr sz="1600" dirty="0" err="1">
+                <a:solidFill>
+                  <a:srgbClr val="CBD5E1"/>
+                </a:solidFill>
+              </a:rPr>
+              <a:t>именно</a:t>
+            </a:r>
+            <a:r>
+              <a:rPr sz="1600" dirty="0">
+                <a:solidFill>
+                  <a:srgbClr val="CBD5E1"/>
+                </a:solidFill>
+              </a:rPr>
+              <a:t> </a:t>
+            </a:r>
+            <a:r>
+              <a:rPr sz="1600" dirty="0" err="1">
+                <a:solidFill>
+                  <a:srgbClr val="CBD5E1"/>
+                </a:solidFill>
+              </a:rPr>
+              <a:t>этого</a:t>
+            </a:r>
+            <a:r>
+              <a:rPr sz="1600" dirty="0">
+                <a:solidFill>
+                  <a:srgbClr val="CBD5E1"/>
+                </a:solidFill>
+              </a:rPr>
+              <a:t> </a:t>
+            </a:r>
+            <a:r>
+              <a:rPr sz="1600" dirty="0" err="1">
+                <a:solidFill>
+                  <a:srgbClr val="CBD5E1"/>
+                </a:solidFill>
+              </a:rPr>
+              <a:t>чата</a:t>
+            </a:r>
+            <a:r>
+              <a:rPr sz="1600" dirty="0">
+                <a:solidFill>
+                  <a:srgbClr val="CBD5E1"/>
+                </a:solidFill>
+              </a:rPr>
+              <a:t>.</a:t>
+            </a:r>
+            <a:endParaRPr lang="ru-RU" sz="1600" dirty="0">
+              <a:solidFill>
+                <a:srgbClr val="CBD5E1"/>
+              </a:solidFill>
+            </a:endParaRPr>
+          </a:p>
+          <a:p>
+            <a:pPr>
+              <a:defRPr sz="1200">
+                <a:latin typeface="Segoe UI"/>
+              </a:defRPr>
+            </a:pPr>
+            <a:endParaRPr sz="1600" dirty="0">
+              <a:solidFill>
+                <a:srgbClr val="CBD5E1"/>
+              </a:solidFill>
+            </a:endParaRPr>
+          </a:p>
+          <a:p>
+            <a:pPr>
+              <a:defRPr sz="1200">
+                <a:latin typeface="Segoe UI"/>
+              </a:defRPr>
+            </a:pPr>
+            <a:r>
+              <a:rPr sz="1600" b="1" dirty="0">
+                <a:solidFill>
+                  <a:srgbClr val="10B981"/>
+                </a:solidFill>
+              </a:rPr>
+              <a:t>• </a:t>
+            </a:r>
+            <a:r>
+              <a:rPr sz="1600" b="1" dirty="0" err="1">
+                <a:solidFill>
+                  <a:srgbClr val="10B981"/>
+                </a:solidFill>
+              </a:rPr>
+              <a:t>Помогает</a:t>
+            </a:r>
+            <a:r>
+              <a:rPr sz="1600" b="1" dirty="0">
+                <a:solidFill>
+                  <a:srgbClr val="10B981"/>
+                </a:solidFill>
+              </a:rPr>
+              <a:t> в </a:t>
+            </a:r>
+            <a:r>
+              <a:rPr sz="1600" b="1" dirty="0" err="1">
+                <a:solidFill>
+                  <a:srgbClr val="10B981"/>
+                </a:solidFill>
+              </a:rPr>
+              <a:t>любых</a:t>
+            </a:r>
+            <a:r>
+              <a:rPr sz="1600" b="1" dirty="0">
+                <a:solidFill>
+                  <a:srgbClr val="10B981"/>
+                </a:solidFill>
+              </a:rPr>
+              <a:t> </a:t>
+            </a:r>
+            <a:r>
+              <a:rPr sz="1600" b="1" dirty="0" err="1">
+                <a:solidFill>
+                  <a:srgbClr val="10B981"/>
+                </a:solidFill>
+              </a:rPr>
+              <a:t>сферах</a:t>
+            </a:r>
+            <a:r>
+              <a:rPr sz="1600" b="1" dirty="0">
+                <a:solidFill>
+                  <a:srgbClr val="10B981"/>
+                </a:solidFill>
+              </a:rPr>
+              <a:t>: </a:t>
+            </a:r>
+            <a:r>
+              <a:rPr sz="1600" dirty="0">
+                <a:solidFill>
+                  <a:srgbClr val="CBD5E1"/>
+                </a:solidFill>
+              </a:rPr>
+              <a:t>P2P-торговля (</a:t>
+            </a:r>
+            <a:r>
+              <a:rPr sz="1600" dirty="0" err="1">
+                <a:solidFill>
+                  <a:srgbClr val="CBD5E1"/>
+                </a:solidFill>
+              </a:rPr>
+              <a:t>сбить</a:t>
+            </a:r>
+            <a:r>
+              <a:rPr sz="1600" dirty="0">
+                <a:solidFill>
+                  <a:srgbClr val="CBD5E1"/>
+                </a:solidFill>
+              </a:rPr>
+              <a:t> </a:t>
+            </a:r>
+            <a:r>
+              <a:rPr sz="1600" dirty="0" err="1">
+                <a:solidFill>
+                  <a:srgbClr val="CBD5E1"/>
+                </a:solidFill>
+              </a:rPr>
+              <a:t>цену</a:t>
+            </a:r>
+            <a:r>
+              <a:rPr sz="1600" dirty="0">
+                <a:solidFill>
+                  <a:srgbClr val="CBD5E1"/>
+                </a:solidFill>
+              </a:rPr>
+              <a:t>), </a:t>
+            </a:r>
+            <a:r>
+              <a:rPr sz="1600" dirty="0" err="1">
+                <a:solidFill>
+                  <a:srgbClr val="CBD5E1"/>
+                </a:solidFill>
+              </a:rPr>
+              <a:t>рабочие</a:t>
+            </a:r>
+            <a:r>
+              <a:rPr sz="1600" dirty="0">
+                <a:solidFill>
+                  <a:srgbClr val="CBD5E1"/>
+                </a:solidFill>
+              </a:rPr>
+              <a:t> </a:t>
+            </a:r>
+            <a:r>
+              <a:rPr sz="1600" dirty="0" err="1">
+                <a:solidFill>
+                  <a:srgbClr val="CBD5E1"/>
+                </a:solidFill>
+              </a:rPr>
+              <a:t>чаты</a:t>
+            </a:r>
+            <a:r>
+              <a:rPr sz="1600" dirty="0">
+                <a:solidFill>
+                  <a:srgbClr val="CBD5E1"/>
+                </a:solidFill>
+              </a:rPr>
+              <a:t> (</a:t>
+            </a:r>
+            <a:r>
+              <a:rPr sz="1600" dirty="0" err="1">
+                <a:solidFill>
+                  <a:srgbClr val="CBD5E1"/>
+                </a:solidFill>
+              </a:rPr>
+              <a:t>снять</a:t>
+            </a:r>
+            <a:r>
+              <a:rPr sz="1600" dirty="0">
+                <a:solidFill>
+                  <a:srgbClr val="CBD5E1"/>
+                </a:solidFill>
+              </a:rPr>
+              <a:t> </a:t>
+            </a:r>
+            <a:r>
+              <a:rPr sz="1600" dirty="0" err="1">
+                <a:solidFill>
+                  <a:srgbClr val="CBD5E1"/>
+                </a:solidFill>
+              </a:rPr>
+              <a:t>накал</a:t>
+            </a:r>
+            <a:r>
+              <a:rPr sz="1600" dirty="0">
+                <a:solidFill>
+                  <a:srgbClr val="CBD5E1"/>
+                </a:solidFill>
+              </a:rPr>
+              <a:t>), </a:t>
+            </a:r>
+            <a:r>
+              <a:rPr sz="1600" dirty="0" err="1">
+                <a:solidFill>
+                  <a:srgbClr val="CBD5E1"/>
+                </a:solidFill>
+              </a:rPr>
+              <a:t>дейтинг</a:t>
+            </a:r>
+            <a:r>
+              <a:rPr sz="1600" dirty="0">
+                <a:solidFill>
+                  <a:srgbClr val="CBD5E1"/>
+                </a:solidFill>
+              </a:rPr>
+              <a:t> и </a:t>
+            </a:r>
+            <a:r>
+              <a:rPr sz="1600" dirty="0" err="1">
+                <a:solidFill>
+                  <a:srgbClr val="CBD5E1"/>
+                </a:solidFill>
+              </a:rPr>
+              <a:t>защита</a:t>
+            </a:r>
+            <a:r>
+              <a:rPr sz="1600" dirty="0">
+                <a:solidFill>
+                  <a:srgbClr val="CBD5E1"/>
+                </a:solidFill>
+              </a:rPr>
+              <a:t> </a:t>
+            </a:r>
+            <a:r>
+              <a:rPr sz="1600" dirty="0" err="1">
+                <a:solidFill>
+                  <a:srgbClr val="CBD5E1"/>
+                </a:solidFill>
+              </a:rPr>
+              <a:t>личных</a:t>
+            </a:r>
+            <a:r>
+              <a:rPr sz="1600" dirty="0">
+                <a:solidFill>
+                  <a:srgbClr val="CBD5E1"/>
+                </a:solidFill>
+              </a:rPr>
+              <a:t> </a:t>
+            </a:r>
+            <a:r>
+              <a:rPr sz="1600" dirty="0" err="1">
+                <a:solidFill>
+                  <a:srgbClr val="CBD5E1"/>
+                </a:solidFill>
+              </a:rPr>
+              <a:t>границ</a:t>
+            </a:r>
+            <a:r>
+              <a:rPr sz="1600" dirty="0">
+                <a:solidFill>
+                  <a:srgbClr val="CBD5E1"/>
+                </a:solidFill>
+              </a:rPr>
+              <a:t>.</a:t>
             </a:r>
           </a:p>
         </p:txBody>
@@ -4184,7 +5514,7 @@
 </file>
 
 <file path=ppt/slides/slide3.xml><?xml version="1.0" encoding="utf-8"?>
-<p:sld xmlns:a="http://schemas.openxmlformats.org/drawingml/2006/main" xmlns:p="http://schemas.openxmlformats.org/presentationml/2006/main" xmlns:r="http://schemas.openxmlformats.org/officeDocument/2006/relationships">
+<p:sld xmlns:a="http://schemas.openxmlformats.org/drawingml/2006/main" xmlns:r="http://schemas.openxmlformats.org/officeDocument/2006/relationships" xmlns:p="http://schemas.openxmlformats.org/presentationml/2006/main">
   <p:cSld>
     <p:spTree>
       <p:nvGrpSpPr>
@@ -4192,7 +5522,14 @@
         <p:cNvGrpSpPr/>
         <p:nvPr/>
       </p:nvGrpSpPr>
-      <p:grpSpPr/>
+      <p:grpSpPr>
+        <a:xfrm>
+          <a:off x="0" y="0"/>
+          <a:ext cx="0" cy="0"/>
+          <a:chOff x="0" y="0"/>
+          <a:chExt cx="0" cy="0"/>
+        </a:xfrm>
+      </p:grpSpPr>
       <p:sp>
         <p:nvSpPr>
           <p:cNvPr id="2" name="Rectangle 1"/>
@@ -4233,6 +5570,7 @@
           <a:lstStyle/>
           <a:p>
             <a:pPr algn="ctr"/>
+            <a:endParaRPr/>
           </a:p>
         </p:txBody>
       </p:sp>
@@ -4274,7 +5612,7 @@
           </a:fontRef>
         </p:style>
         <p:txBody>
-          <a:bodyPr rtlCol="0" anchor="ctr" wrap="square" lIns="0" rIns="0" tIns="0" bIns="0"/>
+          <a:bodyPr wrap="square" lIns="0" tIns="0" rIns="0" bIns="0" rtlCol="0" anchor="ctr"/>
           <a:lstStyle/>
           <a:p>
             <a:pPr algn="ctr">
@@ -4300,7 +5638,7 @@
         <p:spPr>
           <a:xfrm>
             <a:off x="1097280" y="1188720"/>
-            <a:ext cx="9966960" cy="914400"/>
+            <a:ext cx="9966960" cy="723275"/>
           </a:xfrm>
           <a:prstGeom prst="rect">
             <a:avLst/>
@@ -4322,8 +5660,58 @@
               </a:defRPr>
             </a:pPr>
             <a:r>
-              <a:t>Как работает сервис: от скриншота к готовому ответу</a:t>
-            </a:r>
+              <a:rPr dirty="0" err="1"/>
+              <a:t>Как</a:t>
+            </a:r>
+            <a:r>
+              <a:rPr dirty="0"/>
+              <a:t> </a:t>
+            </a:r>
+            <a:r>
+              <a:rPr dirty="0" err="1"/>
+              <a:t>работает</a:t>
+            </a:r>
+            <a:r>
+              <a:rPr dirty="0"/>
+              <a:t> </a:t>
+            </a:r>
+            <a:r>
+              <a:rPr dirty="0" err="1"/>
+              <a:t>сервис</a:t>
+            </a:r>
+            <a:r>
+              <a:rPr dirty="0"/>
+              <a:t>: </a:t>
+            </a:r>
+            <a:r>
+              <a:rPr dirty="0" err="1"/>
+              <a:t>от</a:t>
+            </a:r>
+            <a:r>
+              <a:rPr dirty="0"/>
+              <a:t> </a:t>
+            </a:r>
+            <a:r>
+              <a:rPr dirty="0" err="1"/>
+              <a:t>скриншота</a:t>
+            </a:r>
+            <a:r>
+              <a:rPr dirty="0"/>
+              <a:t> к </a:t>
+            </a:r>
+            <a:r>
+              <a:rPr dirty="0" err="1"/>
+              <a:t>готовому</a:t>
+            </a:r>
+            <a:r>
+              <a:rPr dirty="0"/>
+              <a:t> </a:t>
+            </a:r>
+            <a:r>
+              <a:rPr dirty="0" err="1"/>
+              <a:t>ответу</a:t>
+            </a:r>
+            <a:endParaRPr dirty="0"/>
           </a:p>
           <a:p>
             <a:pPr>
@@ -4335,7 +5723,88 @@
               </a:defRPr>
             </a:pPr>
             <a:r>
-              <a:t>Быстрый цикл работы прямо во время переписки (занимает менее 2 секунд):</a:t>
+              <a:rPr dirty="0" err="1"/>
+              <a:t>Быстрый</a:t>
+            </a:r>
+            <a:r>
+              <a:rPr dirty="0"/>
+              <a:t> </a:t>
+            </a:r>
+            <a:r>
+              <a:rPr dirty="0" err="1"/>
+              <a:t>цикл</a:t>
+            </a:r>
+            <a:r>
+              <a:rPr dirty="0"/>
+              <a:t> </a:t>
+            </a:r>
+            <a:r>
+              <a:rPr dirty="0" err="1"/>
+              <a:t>работы</a:t>
+            </a:r>
+            <a:r>
+              <a:rPr dirty="0"/>
+              <a:t> </a:t>
+            </a:r>
+            <a:r>
+              <a:rPr dirty="0" err="1"/>
+              <a:t>прямо</a:t>
+            </a:r>
+            <a:r>
+              <a:rPr dirty="0"/>
+              <a:t> </a:t>
+            </a:r>
+            <a:r>
+              <a:rPr dirty="0" err="1"/>
+              <a:t>во</a:t>
+            </a:r>
+            <a:r>
+              <a:rPr dirty="0"/>
+              <a:t> </a:t>
+            </a:r>
+            <a:r>
+              <a:rPr dirty="0" err="1"/>
+              <a:t>время</a:t>
+            </a:r>
+            <a:r>
+              <a:rPr dirty="0"/>
+              <a:t> </a:t>
+            </a:r>
+            <a:r>
+              <a:rPr dirty="0" err="1"/>
+              <a:t>переписки</a:t>
+            </a:r>
+            <a:r>
+              <a:rPr dirty="0"/>
+              <a:t> (</a:t>
+            </a:r>
+            <a:r>
+              <a:rPr dirty="0" err="1"/>
+              <a:t>занимает</a:t>
+            </a:r>
+            <a:r>
+              <a:rPr dirty="0"/>
+              <a:t> </a:t>
+            </a:r>
+            <a:r>
+              <a:rPr dirty="0" err="1"/>
+              <a:t>менее</a:t>
+            </a:r>
+            <a:r>
+              <a:rPr dirty="0"/>
+              <a:t> </a:t>
+            </a:r>
+            <a:r>
+              <a:rPr lang="ru-RU" dirty="0"/>
+              <a:t>10 </a:t>
+            </a:r>
+            <a:r>
+              <a:rPr dirty="0" err="1"/>
+              <a:t>секунд</a:t>
+            </a:r>
+            <a:r>
+              <a:rPr dirty="0"/>
+              <a:t>):</a:t>
             </a:r>
           </a:p>
         </p:txBody>
@@ -4382,6 +5851,7 @@
           <a:lstStyle/>
           <a:p>
             <a:pPr algn="ctr"/>
+            <a:endParaRPr/>
           </a:p>
         </p:txBody>
       </p:sp>
@@ -4394,7 +5864,7 @@
         <p:spPr>
           <a:xfrm>
             <a:off x="1280160" y="2468880"/>
-            <a:ext cx="1965960" cy="1463040"/>
+            <a:ext cx="1965960" cy="1292662"/>
           </a:xfrm>
           <a:prstGeom prst="rect">
             <a:avLst/>
@@ -4416,6 +5886,7 @@
               </a:defRPr>
             </a:pPr>
             <a:r>
+              <a:rPr dirty="0"/>
               <a:t>01 • Alt + S</a:t>
             </a:r>
           </a:p>
@@ -4429,8 +5900,50 @@
               </a:defRPr>
             </a:pPr>
             <a:r>
-              <a:t>Открытие плавающего окна поверх любого мессенджера</a:t>
-            </a:r>
+              <a:rPr sz="1600" dirty="0" err="1"/>
+              <a:t>Открытие</a:t>
+            </a:r>
+            <a:r>
+              <a:rPr sz="1600" dirty="0"/>
+              <a:t> </a:t>
+            </a:r>
+            <a:r>
+              <a:rPr sz="1600" dirty="0" err="1"/>
+              <a:t>плавающего</a:t>
+            </a:r>
+            <a:r>
+              <a:rPr sz="1600" dirty="0"/>
+              <a:t> </a:t>
+            </a:r>
+            <a:r>
+              <a:rPr sz="1600" dirty="0" err="1"/>
+              <a:t>окна</a:t>
+            </a:r>
+            <a:r>
+              <a:rPr sz="1600" dirty="0"/>
+              <a:t> </a:t>
+            </a:r>
+            <a:r>
+              <a:rPr sz="1600" dirty="0" err="1"/>
+              <a:t>поверх</a:t>
+            </a:r>
+            <a:r>
+              <a:rPr sz="1600" dirty="0"/>
+              <a:t> </a:t>
+            </a:r>
+            <a:r>
+              <a:rPr sz="1600" dirty="0" err="1"/>
+              <a:t>любого</a:t>
+            </a:r>
+            <a:r>
+              <a:rPr sz="1600" dirty="0"/>
+              <a:t> </a:t>
+            </a:r>
+            <a:r>
+              <a:rPr sz="1600" dirty="0" err="1"/>
+              <a:t>мессенджера</a:t>
+            </a:r>
+            <a:endParaRPr sz="1600" dirty="0"/>
           </a:p>
         </p:txBody>
       </p:sp>
@@ -4476,6 +5989,7 @@
           <a:lstStyle/>
           <a:p>
             <a:pPr algn="ctr"/>
+            <a:endParaRPr/>
           </a:p>
         </p:txBody>
       </p:sp>
@@ -4488,7 +6002,7 @@
         <p:spPr>
           <a:xfrm>
             <a:off x="3822192" y="2468880"/>
-            <a:ext cx="1965960" cy="1463040"/>
+            <a:ext cx="1965960" cy="1292662"/>
           </a:xfrm>
           <a:prstGeom prst="rect">
             <a:avLst/>
@@ -4510,8 +6024,14 @@
               </a:defRPr>
             </a:pPr>
             <a:r>
-              <a:t>02 • Снимок</a:t>
-            </a:r>
+              <a:rPr dirty="0"/>
+              <a:t>02 • </a:t>
+            </a:r>
+            <a:r>
+              <a:rPr dirty="0" err="1"/>
+              <a:t>Снимок</a:t>
+            </a:r>
+            <a:endParaRPr dirty="0"/>
           </a:p>
           <a:p>
             <a:pPr>
@@ -4523,7 +6043,52 @@
               </a:defRPr>
             </a:pPr>
             <a:r>
-              <a:t>Выделение области чата (до 10 скриншотов подряд)</a:t>
+              <a:rPr sz="1600" dirty="0" err="1"/>
+              <a:t>Выделение</a:t>
+            </a:r>
+            <a:r>
+              <a:rPr sz="1600" dirty="0"/>
+              <a:t> </a:t>
+            </a:r>
+            <a:r>
+              <a:rPr sz="1600" dirty="0" err="1"/>
+              <a:t>области</a:t>
+            </a:r>
+            <a:r>
+              <a:rPr sz="1600" dirty="0"/>
+              <a:t> </a:t>
+            </a:r>
+            <a:r>
+              <a:rPr sz="1600" dirty="0" err="1"/>
+              <a:t>чата</a:t>
+            </a:r>
+            <a:r>
+              <a:rPr sz="1600" dirty="0"/>
+              <a:t> (</a:t>
+            </a:r>
+            <a:r>
+              <a:rPr sz="1600" dirty="0" err="1"/>
+              <a:t>до</a:t>
+            </a:r>
+            <a:r>
+              <a:rPr sz="1600" dirty="0"/>
+              <a:t> 10 </a:t>
+            </a:r>
+            <a:r>
+              <a:rPr sz="1600" dirty="0" err="1"/>
+              <a:t>скриншотов</a:t>
+            </a:r>
+            <a:r>
+              <a:rPr sz="1600" dirty="0"/>
+              <a:t> </a:t>
+            </a:r>
+            <a:r>
+              <a:rPr sz="1600" dirty="0" err="1"/>
+              <a:t>подряд</a:t>
+            </a:r>
+            <a:r>
+              <a:rPr sz="1600" dirty="0"/>
+              <a:t>)</a:t>
             </a:r>
           </a:p>
         </p:txBody>
@@ -4570,6 +6135,7 @@
           <a:lstStyle/>
           <a:p>
             <a:pPr algn="ctr"/>
+            <a:endParaRPr/>
           </a:p>
         </p:txBody>
       </p:sp>
@@ -4582,7 +6148,7 @@
         <p:spPr>
           <a:xfrm>
             <a:off x="6364224" y="2468880"/>
-            <a:ext cx="1965960" cy="1463040"/>
+            <a:ext cx="1965960" cy="1292662"/>
           </a:xfrm>
           <a:prstGeom prst="rect">
             <a:avLst/>
@@ -4604,8 +6170,14 @@
               </a:defRPr>
             </a:pPr>
             <a:r>
-              <a:t>03 • Цель</a:t>
-            </a:r>
+              <a:rPr dirty="0"/>
+              <a:t>03 • </a:t>
+            </a:r>
+            <a:r>
+              <a:rPr dirty="0" err="1"/>
+              <a:t>Цель</a:t>
+            </a:r>
+            <a:endParaRPr dirty="0"/>
           </a:p>
           <a:p>
             <a:pPr>
@@ -4617,8 +6189,66 @@
               </a:defRPr>
             </a:pPr>
             <a:r>
-              <a:t>Выбор пресета (Торг, Накал, Влиться) или свой текст</a:t>
-            </a:r>
+              <a:rPr sz="1600" dirty="0" err="1"/>
+              <a:t>Выбор</a:t>
+            </a:r>
+            <a:r>
+              <a:rPr sz="1600" dirty="0"/>
+              <a:t> </a:t>
+            </a:r>
+            <a:r>
+              <a:rPr sz="1600" dirty="0" err="1"/>
+              <a:t>пресета</a:t>
+            </a:r>
+            <a:r>
+              <a:rPr sz="1600" dirty="0"/>
+              <a:t> (</a:t>
+            </a:r>
+            <a:r>
+              <a:rPr sz="1600" dirty="0" err="1"/>
+              <a:t>Торг</a:t>
+            </a:r>
+            <a:r>
+              <a:rPr sz="1600" dirty="0"/>
+              <a:t>, </a:t>
+            </a:r>
+            <a:r>
+              <a:rPr sz="1600" dirty="0" err="1"/>
+              <a:t>Накал</a:t>
+            </a:r>
+            <a:r>
+              <a:rPr sz="1600" dirty="0"/>
+              <a:t>, </a:t>
+            </a:r>
+            <a:r>
+              <a:rPr sz="1600" dirty="0" err="1"/>
+              <a:t>Влиться</a:t>
+            </a:r>
+            <a:r>
+              <a:rPr sz="1600" dirty="0"/>
+              <a:t>) </a:t>
+            </a:r>
+            <a:r>
+              <a:rPr sz="1600" dirty="0" err="1"/>
+              <a:t>или</a:t>
+            </a:r>
+            <a:r>
+              <a:rPr sz="1600" dirty="0"/>
+              <a:t> </a:t>
+            </a:r>
+            <a:r>
+              <a:rPr sz="1600" dirty="0" err="1"/>
+              <a:t>свой</a:t>
+            </a:r>
+            <a:r>
+              <a:rPr sz="1600" dirty="0"/>
+              <a:t> </a:t>
+            </a:r>
+            <a:r>
+              <a:rPr sz="1600" dirty="0" err="1"/>
+              <a:t>текст</a:t>
+            </a:r>
+            <a:endParaRPr sz="1600" dirty="0"/>
           </a:p>
         </p:txBody>
       </p:sp>
@@ -4664,6 +6294,7 @@
           <a:lstStyle/>
           <a:p>
             <a:pPr algn="ctr"/>
+            <a:endParaRPr/>
           </a:p>
         </p:txBody>
       </p:sp>
@@ -4676,7 +6307,7 @@
         <p:spPr>
           <a:xfrm>
             <a:off x="8906256" y="2468880"/>
-            <a:ext cx="1965960" cy="1463040"/>
+            <a:ext cx="1965960" cy="1292662"/>
           </a:xfrm>
           <a:prstGeom prst="rect">
             <a:avLst/>
@@ -4698,8 +6329,14 @@
               </a:defRPr>
             </a:pPr>
             <a:r>
-              <a:t>04 • 1 клик</a:t>
-            </a:r>
+              <a:rPr dirty="0"/>
+              <a:t>04 • 1 </a:t>
+            </a:r>
+            <a:r>
+              <a:rPr dirty="0" err="1"/>
+              <a:t>клик</a:t>
+            </a:r>
+            <a:endParaRPr dirty="0"/>
           </a:p>
           <a:p>
             <a:pPr>
@@ -4711,8 +6348,58 @@
               </a:defRPr>
             </a:pPr>
             <a:r>
-              <a:t>Готовый ответ копируется в буфер обмена для вставки</a:t>
-            </a:r>
+              <a:rPr sz="1600" dirty="0" err="1"/>
+              <a:t>Готовый</a:t>
+            </a:r>
+            <a:r>
+              <a:rPr sz="1600" dirty="0"/>
+              <a:t> </a:t>
+            </a:r>
+            <a:r>
+              <a:rPr sz="1600" dirty="0" err="1"/>
+              <a:t>ответ</a:t>
+            </a:r>
+            <a:r>
+              <a:rPr sz="1600" dirty="0"/>
+              <a:t> </a:t>
+            </a:r>
+            <a:r>
+              <a:rPr sz="1600" dirty="0" err="1"/>
+              <a:t>копируется</a:t>
+            </a:r>
+            <a:r>
+              <a:rPr sz="1600" dirty="0"/>
+              <a:t> в </a:t>
+            </a:r>
+            <a:r>
+              <a:rPr sz="1600" dirty="0" err="1"/>
+              <a:t>буфер</a:t>
+            </a:r>
+            <a:r>
+              <a:rPr sz="1600" dirty="0"/>
+              <a:t> </a:t>
+            </a:r>
+            <a:r>
+              <a:rPr sz="1600" dirty="0" err="1"/>
+              <a:t>обмена</a:t>
+            </a:r>
+            <a:r>
+              <a:rPr sz="1600" dirty="0"/>
+              <a:t> </a:t>
+            </a:r>
+            <a:r>
+              <a:rPr sz="1600" dirty="0" err="1"/>
+              <a:t>для</a:t>
+            </a:r>
+            <a:r>
+              <a:rPr sz="1600" dirty="0"/>
+              <a:t> </a:t>
+            </a:r>
+            <a:r>
+              <a:rPr sz="1600" dirty="0" err="1"/>
+              <a:t>вставки</a:t>
+            </a:r>
+            <a:endParaRPr sz="1600" dirty="0"/>
           </a:p>
         </p:txBody>
       </p:sp>
@@ -4758,6 +6445,7 @@
           <a:lstStyle/>
           <a:p>
             <a:pPr algn="ctr"/>
+            <a:endParaRPr/>
           </a:p>
         </p:txBody>
       </p:sp>
@@ -4770,7 +6458,7 @@
         <p:spPr>
           <a:xfrm>
             <a:off x="1280160" y="4480560"/>
-            <a:ext cx="4480560" cy="1600199"/>
+            <a:ext cx="4480560" cy="1292662"/>
           </a:xfrm>
           <a:prstGeom prst="rect">
             <a:avLst/>
@@ -4792,8 +6480,38 @@
               </a:defRPr>
             </a:pPr>
             <a:r>
-              <a:t>🎭 Анализ атмосферы и негласных правил</a:t>
-            </a:r>
+              <a:rPr dirty="0"/>
+              <a:t>🎭 </a:t>
+            </a:r>
+            <a:r>
+              <a:rPr dirty="0" err="1"/>
+              <a:t>Анализ</a:t>
+            </a:r>
+            <a:r>
+              <a:rPr dirty="0"/>
+              <a:t> </a:t>
+            </a:r>
+            <a:r>
+              <a:rPr dirty="0" err="1"/>
+              <a:t>атмосферы</a:t>
+            </a:r>
+            <a:r>
+              <a:rPr dirty="0"/>
+              <a:t> и </a:t>
+            </a:r>
+            <a:r>
+              <a:rPr dirty="0" err="1"/>
+              <a:t>негласных</a:t>
+            </a:r>
+            <a:r>
+              <a:rPr dirty="0"/>
+              <a:t> </a:t>
+            </a:r>
+            <a:r>
+              <a:rPr dirty="0" err="1"/>
+              <a:t>правил</a:t>
+            </a:r>
+            <a:endParaRPr dirty="0"/>
           </a:p>
           <a:p>
             <a:pPr>
@@ -4805,7 +6523,132 @@
               </a:defRPr>
             </a:pPr>
             <a:r>
-              <a:t>Модель оценивает накал (1–10 с цветовой индикацией), дистанцию и скрытые законы чата (например: «не душнить», «писать коротко», «сарказм уместен»).</a:t>
+              <a:rPr sz="1600" dirty="0" err="1"/>
+              <a:t>Модель</a:t>
+            </a:r>
+            <a:r>
+              <a:rPr sz="1600" dirty="0"/>
+              <a:t> </a:t>
+            </a:r>
+            <a:r>
+              <a:rPr sz="1600" dirty="0" err="1"/>
+              <a:t>оценивает</a:t>
+            </a:r>
+            <a:r>
+              <a:rPr sz="1600" dirty="0"/>
+              <a:t> </a:t>
+            </a:r>
+            <a:r>
+              <a:rPr sz="1600" dirty="0" err="1"/>
+              <a:t>накал</a:t>
+            </a:r>
+            <a:r>
+              <a:rPr sz="1600" dirty="0"/>
+              <a:t> (1–10 с </a:t>
+            </a:r>
+            <a:r>
+              <a:rPr sz="1600" dirty="0" err="1"/>
+              <a:t>цветовой</a:t>
+            </a:r>
+            <a:r>
+              <a:rPr sz="1600" dirty="0"/>
+              <a:t> </a:t>
+            </a:r>
+            <a:r>
+              <a:rPr sz="1600" dirty="0" err="1"/>
+              <a:t>индикацией</a:t>
+            </a:r>
+            <a:r>
+              <a:rPr sz="1600" dirty="0"/>
+              <a:t>), </a:t>
+            </a:r>
+            <a:r>
+              <a:rPr sz="1600" dirty="0" err="1"/>
+              <a:t>дистанцию</a:t>
+            </a:r>
+            <a:r>
+              <a:rPr sz="1600" dirty="0"/>
+              <a:t> и </a:t>
+            </a:r>
+            <a:r>
+              <a:rPr sz="1600" dirty="0" err="1"/>
+              <a:t>скрытые</a:t>
+            </a:r>
+            <a:r>
+              <a:rPr sz="1600" dirty="0"/>
+              <a:t> </a:t>
+            </a:r>
+            <a:r>
+              <a:rPr sz="1600" dirty="0" err="1"/>
+              <a:t>законы</a:t>
+            </a:r>
+            <a:r>
+              <a:rPr sz="1600" dirty="0"/>
+              <a:t> </a:t>
+            </a:r>
+            <a:r>
+              <a:rPr sz="1600" dirty="0" err="1"/>
+              <a:t>чата</a:t>
+            </a:r>
+            <a:r>
+              <a:rPr sz="1600" dirty="0"/>
+              <a:t> (</a:t>
+            </a:r>
+            <a:r>
+              <a:rPr sz="1600" dirty="0" err="1"/>
+              <a:t>например</a:t>
+            </a:r>
+            <a:r>
+              <a:rPr sz="1600" dirty="0"/>
+              <a:t>: «</a:t>
+            </a:r>
+            <a:r>
+              <a:rPr sz="1600" dirty="0" err="1"/>
+              <a:t>не</a:t>
+            </a:r>
+            <a:r>
+              <a:rPr sz="1600" dirty="0"/>
+              <a:t> </a:t>
+            </a:r>
+            <a:r>
+              <a:rPr sz="1600" dirty="0" err="1"/>
+              <a:t>душнить</a:t>
+            </a:r>
+            <a:r>
+              <a:rPr sz="1600" dirty="0"/>
+              <a:t>», «</a:t>
+            </a:r>
+            <a:r>
+              <a:rPr sz="1600" dirty="0" err="1"/>
+              <a:t>писать</a:t>
+            </a:r>
+            <a:r>
+              <a:rPr sz="1600" dirty="0"/>
+              <a:t> </a:t>
+            </a:r>
+            <a:r>
+              <a:rPr sz="1600" dirty="0" err="1"/>
+              <a:t>коротко</a:t>
+            </a:r>
+            <a:r>
+              <a:rPr sz="1600" dirty="0"/>
+              <a:t>», «</a:t>
+            </a:r>
+            <a:r>
+              <a:rPr sz="1600" dirty="0" err="1"/>
+              <a:t>сарказм</a:t>
+            </a:r>
+            <a:r>
+              <a:rPr sz="1600" dirty="0"/>
+              <a:t> </a:t>
+            </a:r>
+            <a:r>
+              <a:rPr sz="1600" dirty="0" err="1"/>
+              <a:t>уместен</a:t>
+            </a:r>
+            <a:r>
+              <a:rPr sz="1600" dirty="0"/>
+              <a:t>»).</a:t>
             </a:r>
           </a:p>
         </p:txBody>
@@ -4852,6 +6695,7 @@
           <a:lstStyle/>
           <a:p>
             <a:pPr algn="ctr"/>
+            <a:endParaRPr/>
           </a:p>
         </p:txBody>
       </p:sp>
@@ -4886,8 +6730,38 @@
               </a:defRPr>
             </a:pPr>
             <a:r>
-              <a:t>✍️ Аудит черновика и адаптивные ответы</a:t>
-            </a:r>
+              <a:rPr dirty="0"/>
+              <a:t>✍️ </a:t>
+            </a:r>
+            <a:r>
+              <a:rPr dirty="0" err="1"/>
+              <a:t>Аудит</a:t>
+            </a:r>
+            <a:r>
+              <a:rPr dirty="0"/>
+              <a:t> </a:t>
+            </a:r>
+            <a:r>
+              <a:rPr dirty="0" err="1"/>
+              <a:t>черновика</a:t>
+            </a:r>
+            <a:r>
+              <a:rPr dirty="0"/>
+              <a:t> и </a:t>
+            </a:r>
+            <a:r>
+              <a:rPr dirty="0" err="1"/>
+              <a:t>адаптивные</a:t>
+            </a:r>
+            <a:r>
+              <a:rPr dirty="0"/>
+              <a:t> </a:t>
+            </a:r>
+            <a:r>
+              <a:rPr dirty="0" err="1"/>
+              <a:t>ответы</a:t>
+            </a:r>
+            <a:endParaRPr dirty="0"/>
           </a:p>
           <a:p>
             <a:pPr>
@@ -4899,7 +6773,164 @@
               </a:defRPr>
             </a:pPr>
             <a:r>
-              <a:t>Если вписан черновик ответа, ИИ укажет на его риски. На выбор дается 3–4 готовых стиля (твердый, дипломатичный, дружелюбный) с обоснованием эффекта каждой фразы.</a:t>
+              <a:rPr sz="1600" dirty="0" err="1"/>
+              <a:t>Если</a:t>
+            </a:r>
+            <a:r>
+              <a:rPr sz="1600" dirty="0"/>
+              <a:t> </a:t>
+            </a:r>
+            <a:r>
+              <a:rPr sz="1600" dirty="0" err="1"/>
+              <a:t>вписан</a:t>
+            </a:r>
+            <a:r>
+              <a:rPr sz="1600" dirty="0"/>
+              <a:t> </a:t>
+            </a:r>
+            <a:r>
+              <a:rPr sz="1600" dirty="0" err="1"/>
+              <a:t>черновик</a:t>
+            </a:r>
+            <a:r>
+              <a:rPr sz="1600" dirty="0"/>
+              <a:t> </a:t>
+            </a:r>
+            <a:r>
+              <a:rPr sz="1600" dirty="0" err="1"/>
+              <a:t>ответа</a:t>
+            </a:r>
+            <a:r>
+              <a:rPr sz="1600" dirty="0"/>
+              <a:t>, ИИ </a:t>
+            </a:r>
+            <a:r>
+              <a:rPr sz="1600" dirty="0" err="1"/>
+              <a:t>укажет</a:t>
+            </a:r>
+            <a:r>
+              <a:rPr sz="1600" dirty="0"/>
+              <a:t> </a:t>
+            </a:r>
+            <a:r>
+              <a:rPr sz="1600" dirty="0" err="1"/>
+              <a:t>на</a:t>
+            </a:r>
+            <a:r>
+              <a:rPr sz="1600" dirty="0"/>
+              <a:t> </a:t>
+            </a:r>
+            <a:r>
+              <a:rPr sz="1600" dirty="0" err="1"/>
+              <a:t>его</a:t>
+            </a:r>
+            <a:r>
+              <a:rPr sz="1600" dirty="0"/>
+              <a:t> </a:t>
+            </a:r>
+            <a:r>
+              <a:rPr sz="1600" dirty="0" err="1"/>
+              <a:t>риски</a:t>
+            </a:r>
+            <a:r>
+              <a:rPr sz="1600" dirty="0"/>
+              <a:t>. </a:t>
+            </a:r>
+            <a:r>
+              <a:rPr sz="1600" dirty="0" err="1"/>
+              <a:t>На</a:t>
+            </a:r>
+            <a:r>
+              <a:rPr sz="1600" dirty="0"/>
+              <a:t> </a:t>
+            </a:r>
+            <a:r>
+              <a:rPr sz="1600" dirty="0" err="1"/>
+              <a:t>выбор</a:t>
+            </a:r>
+            <a:r>
+              <a:rPr sz="1600" dirty="0"/>
+              <a:t> </a:t>
+            </a:r>
+            <a:r>
+              <a:rPr sz="1600" dirty="0" err="1"/>
+              <a:t>дается</a:t>
+            </a:r>
+            <a:r>
+              <a:rPr sz="1600" dirty="0"/>
+              <a:t> 3–4 </a:t>
+            </a:r>
+            <a:r>
+              <a:rPr sz="1600" dirty="0" err="1"/>
+              <a:t>готовых</a:t>
+            </a:r>
+            <a:r>
+              <a:rPr sz="1600" dirty="0"/>
+              <a:t> </a:t>
+            </a:r>
+            <a:r>
+              <a:rPr sz="1600" dirty="0" err="1"/>
+              <a:t>стиля</a:t>
+            </a:r>
+            <a:r>
+              <a:rPr sz="1600" dirty="0"/>
+              <a:t> (</a:t>
+            </a:r>
+            <a:r>
+              <a:rPr sz="1600" dirty="0" err="1"/>
+              <a:t>твердый</a:t>
+            </a:r>
+            <a:r>
+              <a:rPr sz="1600" dirty="0"/>
+              <a:t>, </a:t>
+            </a:r>
+            <a:r>
+              <a:rPr sz="1600" dirty="0" err="1"/>
+              <a:t>дипломатичный</a:t>
+            </a:r>
+            <a:r>
+              <a:rPr sz="1600" dirty="0"/>
+              <a:t>, </a:t>
+            </a:r>
+            <a:r>
+              <a:rPr sz="1600" dirty="0" err="1"/>
+              <a:t>дружелюбный</a:t>
+            </a:r>
+            <a:r>
+              <a:rPr sz="1600" dirty="0"/>
+              <a:t>) с </a:t>
+            </a:r>
+            <a:r>
+              <a:rPr sz="1600" dirty="0" err="1"/>
+              <a:t>обоснованием</a:t>
+            </a:r>
+            <a:r>
+              <a:rPr sz="1600" dirty="0"/>
+              <a:t> </a:t>
+            </a:r>
+            <a:r>
+              <a:rPr sz="1600" dirty="0" err="1"/>
+              <a:t>эффекта</a:t>
+            </a:r>
+            <a:r>
+              <a:rPr sz="1600" dirty="0"/>
+              <a:t> </a:t>
+            </a:r>
+            <a:r>
+              <a:rPr sz="1600" dirty="0" err="1"/>
+              <a:t>каждой</a:t>
+            </a:r>
+            <a:r>
+              <a:rPr sz="1600" dirty="0"/>
+              <a:t> </a:t>
+            </a:r>
+            <a:r>
+              <a:rPr sz="1600" dirty="0" err="1"/>
+              <a:t>фразы</a:t>
+            </a:r>
+            <a:r>
+              <a:rPr sz="1600" dirty="0"/>
+              <a:t>.</a:t>
             </a:r>
           </a:p>
         </p:txBody>
@@ -4913,7 +6944,7 @@
 </file>
 
 <file path=ppt/slides/slide4.xml><?xml version="1.0" encoding="utf-8"?>
-<p:sld xmlns:a="http://schemas.openxmlformats.org/drawingml/2006/main" xmlns:p="http://schemas.openxmlformats.org/presentationml/2006/main" xmlns:r="http://schemas.openxmlformats.org/officeDocument/2006/relationships">
+<p:sld xmlns:a="http://schemas.openxmlformats.org/drawingml/2006/main" xmlns:r="http://schemas.openxmlformats.org/officeDocument/2006/relationships" xmlns:p="http://schemas.openxmlformats.org/presentationml/2006/main">
   <p:cSld>
     <p:spTree>
       <p:nvGrpSpPr>
@@ -4921,7 +6952,14 @@
         <p:cNvGrpSpPr/>
         <p:nvPr/>
       </p:nvGrpSpPr>
-      <p:grpSpPr/>
+      <p:grpSpPr>
+        <a:xfrm>
+          <a:off x="0" y="0"/>
+          <a:ext cx="0" cy="0"/>
+          <a:chOff x="0" y="0"/>
+          <a:chExt cx="0" cy="0"/>
+        </a:xfrm>
+      </p:grpSpPr>
       <p:sp>
         <p:nvSpPr>
           <p:cNvPr id="2" name="Rectangle 1"/>
@@ -4962,6 +7000,7 @@
           <a:lstStyle/>
           <a:p>
             <a:pPr algn="ctr"/>
+            <a:endParaRPr/>
           </a:p>
         </p:txBody>
       </p:sp>
@@ -5003,7 +7042,7 @@
           </a:fontRef>
         </p:style>
         <p:txBody>
-          <a:bodyPr rtlCol="0" anchor="ctr" wrap="square" lIns="0" rIns="0" tIns="0" bIns="0"/>
+          <a:bodyPr wrap="square" lIns="0" tIns="0" rIns="0" bIns="0" rtlCol="0" anchor="ctr"/>
           <a:lstStyle/>
           <a:p>
             <a:pPr algn="ctr">
@@ -5111,6 +7150,7 @@
           <a:lstStyle/>
           <a:p>
             <a:pPr algn="ctr"/>
+            <a:endParaRPr/>
           </a:p>
         </p:txBody>
       </p:sp>
@@ -5154,6 +7194,7 @@
           <a:lstStyle/>
           <a:p>
             <a:pPr algn="ctr"/>
+            <a:endParaRPr/>
           </a:p>
         </p:txBody>
       </p:sp>
@@ -5261,6 +7302,7 @@
           <a:lstStyle/>
           <a:p>
             <a:pPr algn="ctr"/>
+            <a:endParaRPr/>
           </a:p>
         </p:txBody>
       </p:sp>
@@ -5304,6 +7346,7 @@
           <a:lstStyle/>
           <a:p>
             <a:pPr algn="ctr"/>
+            <a:endParaRPr/>
           </a:p>
         </p:txBody>
       </p:sp>
@@ -5411,6 +7454,7 @@
           <a:lstStyle/>
           <a:p>
             <a:pPr algn="ctr"/>
+            <a:endParaRPr/>
           </a:p>
         </p:txBody>
       </p:sp>
@@ -5454,6 +7498,7 @@
           <a:lstStyle/>
           <a:p>
             <a:pPr algn="ctr"/>
+            <a:endParaRPr/>
           </a:p>
         </p:txBody>
       </p:sp>
@@ -5528,7 +7573,7 @@
 </file>
 
 <file path=ppt/slides/slide5.xml><?xml version="1.0" encoding="utf-8"?>
-<p:sld xmlns:a="http://schemas.openxmlformats.org/drawingml/2006/main" xmlns:p="http://schemas.openxmlformats.org/presentationml/2006/main" xmlns:r="http://schemas.openxmlformats.org/officeDocument/2006/relationships">
+<p:sld xmlns:a="http://schemas.openxmlformats.org/drawingml/2006/main" xmlns:r="http://schemas.openxmlformats.org/officeDocument/2006/relationships" xmlns:p="http://schemas.openxmlformats.org/presentationml/2006/main">
   <p:cSld>
     <p:spTree>
       <p:nvGrpSpPr>
@@ -5536,7 +7581,14 @@
         <p:cNvGrpSpPr/>
         <p:nvPr/>
       </p:nvGrpSpPr>
-      <p:grpSpPr/>
+      <p:grpSpPr>
+        <a:xfrm>
+          <a:off x="0" y="0"/>
+          <a:ext cx="0" cy="0"/>
+          <a:chOff x="0" y="0"/>
+          <a:chExt cx="0" cy="0"/>
+        </a:xfrm>
+      </p:grpSpPr>
       <p:sp>
         <p:nvSpPr>
           <p:cNvPr id="2" name="Rectangle 1"/>
@@ -5577,6 +7629,7 @@
           <a:lstStyle/>
           <a:p>
             <a:pPr algn="ctr"/>
+            <a:endParaRPr/>
           </a:p>
         </p:txBody>
       </p:sp>
@@ -5618,7 +7671,7 @@
           </a:fontRef>
         </p:style>
         <p:txBody>
-          <a:bodyPr rtlCol="0" anchor="ctr" wrap="square" lIns="0" rIns="0" tIns="0" bIns="0"/>
+          <a:bodyPr wrap="square" lIns="0" tIns="0" rIns="0" bIns="0" rtlCol="0" anchor="ctr"/>
           <a:lstStyle/>
           <a:p>
             <a:pPr algn="ctr">
@@ -5726,6 +7779,7 @@
           <a:lstStyle/>
           <a:p>
             <a:pPr algn="ctr"/>
+            <a:endParaRPr/>
           </a:p>
         </p:txBody>
       </p:sp>
@@ -5738,7 +7792,7 @@
         <p:spPr>
           <a:xfrm>
             <a:off x="1280160" y="2514600"/>
-            <a:ext cx="2788920" cy="1737360"/>
+            <a:ext cx="2788920" cy="1138773"/>
           </a:xfrm>
           <a:prstGeom prst="rect">
             <a:avLst/>
@@ -5760,8 +7814,22 @@
               </a:defRPr>
             </a:pPr>
             <a:r>
-              <a:t>&lt; 2 сек</a:t>
-            </a:r>
+              <a:rPr dirty="0"/>
+              <a:t>&lt; </a:t>
+            </a:r>
+            <a:r>
+              <a:rPr lang="ru-RU" dirty="0"/>
+              <a:t>10</a:t>
+            </a:r>
+            <a:r>
+              <a:rPr dirty="0"/>
+              <a:t> </a:t>
+            </a:r>
+            <a:r>
+              <a:rPr dirty="0" err="1"/>
+              <a:t>сек</a:t>
+            </a:r>
+            <a:endParaRPr dirty="0"/>
           </a:p>
           <a:p>
             <a:pPr>
@@ -5773,8 +7841,18 @@
               </a:defRPr>
             </a:pPr>
             <a:r>
-              <a:t>Скорость анализа</a:t>
-            </a:r>
+              <a:rPr dirty="0" err="1"/>
+              <a:t>Скорость</a:t>
+            </a:r>
+            <a:r>
+              <a:rPr dirty="0"/>
+              <a:t> </a:t>
+            </a:r>
+            <a:r>
+              <a:rPr dirty="0" err="1"/>
+              <a:t>анализа</a:t>
+            </a:r>
+            <a:endParaRPr dirty="0"/>
           </a:p>
           <a:p>
             <a:pPr>
@@ -5786,8 +7864,82 @@
               </a:defRPr>
             </a:pPr>
             <a:r>
-              <a:t>От снимка экрана до готовых вариантов ответа под выбранную цель</a:t>
-            </a:r>
+              <a:rPr dirty="0" err="1"/>
+              <a:t>От</a:t>
+            </a:r>
+            <a:r>
+              <a:rPr dirty="0"/>
+              <a:t> </a:t>
+            </a:r>
+            <a:r>
+              <a:rPr dirty="0" err="1"/>
+              <a:t>снимка</a:t>
+            </a:r>
+            <a:r>
+              <a:rPr dirty="0"/>
+              <a:t> </a:t>
+            </a:r>
+            <a:r>
+              <a:rPr dirty="0" err="1"/>
+              <a:t>экрана</a:t>
+            </a:r>
+            <a:r>
+              <a:rPr dirty="0"/>
+              <a:t> </a:t>
+            </a:r>
+            <a:r>
+              <a:rPr dirty="0" err="1"/>
+              <a:t>до</a:t>
+            </a:r>
+            <a:r>
+              <a:rPr dirty="0"/>
+              <a:t> </a:t>
+            </a:r>
+            <a:r>
+              <a:rPr dirty="0" err="1"/>
+              <a:t>готовых</a:t>
+            </a:r>
+            <a:r>
+              <a:rPr dirty="0"/>
+              <a:t> </a:t>
+            </a:r>
+            <a:r>
+              <a:rPr dirty="0" err="1"/>
+              <a:t>вариантов</a:t>
+            </a:r>
+            <a:r>
+              <a:rPr dirty="0"/>
+              <a:t> </a:t>
+            </a:r>
+            <a:r>
+              <a:rPr dirty="0" err="1"/>
+              <a:t>ответа</a:t>
+            </a:r>
+            <a:r>
+              <a:rPr dirty="0"/>
+              <a:t> </a:t>
+            </a:r>
+            <a:r>
+              <a:rPr dirty="0" err="1"/>
+              <a:t>под</a:t>
+            </a:r>
+            <a:r>
+              <a:rPr dirty="0"/>
+              <a:t> </a:t>
+            </a:r>
+            <a:r>
+              <a:rPr dirty="0" err="1"/>
+              <a:t>выбранную</a:t>
+            </a:r>
+            <a:r>
+              <a:rPr dirty="0"/>
+              <a:t> </a:t>
+            </a:r>
+            <a:r>
+              <a:rPr dirty="0" err="1"/>
+              <a:t>цель</a:t>
+            </a:r>
+            <a:endParaRPr dirty="0"/>
           </a:p>
         </p:txBody>
       </p:sp>
@@ -5833,6 +7985,7 @@
           <a:lstStyle/>
           <a:p>
             <a:pPr algn="ctr"/>
+            <a:endParaRPr/>
           </a:p>
         </p:txBody>
       </p:sp>
@@ -5940,6 +8093,7 @@
           <a:lstStyle/>
           <a:p>
             <a:pPr algn="ctr"/>
+            <a:endParaRPr/>
           </a:p>
         </p:txBody>
       </p:sp>
@@ -6047,6 +8201,7 @@
           <a:lstStyle/>
           <a:p>
             <a:pPr algn="ctr"/>
+            <a:endParaRPr/>
           </a:p>
         </p:txBody>
       </p:sp>

</xml_diff>